<commit_message>
Initial commit: FundusAI-Edu project
</commit_message>
<xml_diff>
--- a/slides/output/FundusAI-Edu_项目展示_v2.pptx
+++ b/slides/output/FundusAI-Edu_项目展示_v2.pptx
@@ -4,6 +4,9 @@
   <p:sldMasterIdLst>
     <p:sldMasterId id="2147483648" r:id="rId1"/>
   </p:sldMasterIdLst>
+  <p:notesMasterIdLst>
+    <p:notesMasterId r:id="rId15"/>
+  </p:notesMasterIdLst>
   <p:sldIdLst>
     <p:sldId id="256" r:id="rId2"/>
     <p:sldId id="257" r:id="rId3"/>
@@ -19,10 +22,7 @@
     <p:sldId id="267" r:id="rId13"/>
     <p:sldId id="268" r:id="rId14"/>
   </p:sldIdLst>
-  <p:notesMasterIdLst>
-    <p:notesMasterId r:id="rId15"/>
-  </p:notesMasterIdLst>
-  <p:sldSz cx="9144000" cy="5143500"/>
+  <p:sldSz cx="9144000" cy="5143500" type="screen16x9"/>
   <p:notesSz cx="5143500" cy="9144000"/>
   <p:defaultTextStyle>
     <a:lvl1pPr marL="0" algn="l" defTabSz="914400" rtl="0" eaLnBrk="1" latinLnBrk="0" hangingPunct="1">
@@ -116,6 +116,11 @@
       </a:defRPr>
     </a:lvl9pPr>
   </p:defaultTextStyle>
+  <p:extLst>
+    <p:ext uri="{EFAFB233-063F-42B5-8137-9DF3F51BA10A}">
+      <p15:sldGuideLst xmlns:p15="http://schemas.microsoft.com/office/powerpoint/2012/main"/>
+    </p:ext>
+  </p:extLst>
 </p:presentation>
 </file>
 
@@ -141,234 +146,10 @@
           <a:chExt cx="0" cy="0"/>
         </a:xfrm>
       </p:grpSpPr>
-      <p:sp>
-        <p:nvSpPr>
-          <p:cNvPr id="2" name="Header Placeholder 1"/>
-          <p:cNvSpPr>
-            <a:spLocks noGrp="1"/>
-          </p:cNvSpPr>
-          <p:nvPr>
-            <p:ph type="hdr" sz="quarter"/>
-          </p:nvPr>
-        </p:nvSpPr>
-        <p:spPr>
-          <a:xfrm>
-            <a:off x="0" y="0"/>
-            <a:ext cx="2971800" cy="458788"/>
-          </a:xfrm>
-          <a:prstGeom prst="rect">
-            <a:avLst/>
-          </a:prstGeom>
-        </p:spPr>
-        <p:txBody>
-          <a:bodyPr vert="horz" lIns="91440" tIns="45720" rIns="91440" bIns="45720" rtlCol="0"/>
-          <a:lstStyle>
-            <a:lvl1pPr algn="l">
-              <a:defRPr sz="1200"/>
-            </a:lvl1pPr>
-          </a:lstStyle>
-          <a:p>
-            <a:endParaRPr lang="en-US"/>
-          </a:p>
-        </p:txBody>
-      </p:sp>
-      <p:sp>
-        <p:nvSpPr>
-          <p:cNvPr id="3" name="Date Placeholder 2"/>
-          <p:cNvSpPr>
-            <a:spLocks noGrp="1"/>
-          </p:cNvSpPr>
-          <p:nvPr>
-            <p:ph type="dt" idx="1"/>
-          </p:nvPr>
-        </p:nvSpPr>
-        <p:spPr>
-          <a:xfrm>
-            <a:off x="3884613" y="0"/>
-            <a:ext cx="2971800" cy="458788"/>
-          </a:xfrm>
-          <a:prstGeom prst="rect">
-            <a:avLst/>
-          </a:prstGeom>
-        </p:spPr>
-        <p:txBody>
-          <a:bodyPr vert="horz" lIns="91440" tIns="45720" rIns="91440" bIns="45720" rtlCol="0"/>
-          <a:lstStyle>
-            <a:lvl1pPr algn="r">
-              <a:defRPr sz="1200"/>
-            </a:lvl1pPr>
-          </a:lstStyle>
-          <a:p>
-            <a:fld id="{5282F153-3F37-0F45-9E97-73ACFA13230C}" type="datetimeFigureOut">
-              <a:rPr lang="en-US"/>
-              <a:t>7/23/19</a:t>
-            </a:fld>
-            <a:endParaRPr lang="en-US"/>
-          </a:p>
-        </p:txBody>
-      </p:sp>
-      <p:sp>
-        <p:nvSpPr>
-          <p:cNvPr id="4" name="Slide Image Placeholder 3"/>
-          <p:cNvSpPr>
-            <a:spLocks noGrp="1" noRot="1" noChangeAspect="1"/>
-          </p:cNvSpPr>
-          <p:nvPr>
-            <p:ph type="sldImg" idx="2"/>
-          </p:nvPr>
-        </p:nvSpPr>
-        <p:spPr>
-          <a:xfrm>
-            <a:off x="685800" y="1143000"/>
-            <a:ext cx="5486400" cy="3086100"/>
-          </a:xfrm>
-          <a:prstGeom prst="rect">
-            <a:avLst/>
-          </a:prstGeom>
-          <a:noFill/>
-          <a:ln w="12700">
-            <a:solidFill>
-              <a:prstClr val="black"/>
-            </a:solidFill>
-          </a:ln>
-        </p:spPr>
-        <p:txBody>
-          <a:bodyPr vert="horz" lIns="91440" tIns="45720" rIns="91440" bIns="45720" rtlCol="0" anchor="ctr"/>
-          <a:lstStyle/>
-          <a:p>
-            <a:endParaRPr lang="en-US"/>
-          </a:p>
-        </p:txBody>
-      </p:sp>
-      <p:sp>
-        <p:nvSpPr>
-          <p:cNvPr id="5" name="Notes Placeholder 4"/>
-          <p:cNvSpPr>
-            <a:spLocks noGrp="1"/>
-          </p:cNvSpPr>
-          <p:nvPr>
-            <p:ph type="body" sz="quarter" idx="3"/>
-          </p:nvPr>
-        </p:nvSpPr>
-        <p:spPr>
-          <a:xfrm>
-            <a:off x="685800" y="4400550"/>
-            <a:ext cx="5486400" cy="3600450"/>
-          </a:xfrm>
-          <a:prstGeom prst="rect">
-            <a:avLst/>
-          </a:prstGeom>
-        </p:spPr>
-        <p:txBody>
-          <a:bodyPr vert="horz" lIns="91440" tIns="45720" rIns="91440" bIns="45720" rtlCol="0"/>
-          <a:lstStyle/>
-          <a:p>
-            <a:pPr lvl="0"/>
-            <a:r>
-              <a:rPr lang="en-US"/>
-              <a:t>Click to edit Master text styles</a:t>
-            </a:r>
-          </a:p>
-          <a:p>
-            <a:pPr lvl="1"/>
-            <a:r>
-              <a:rPr lang="en-US"/>
-              <a:t>Second level</a:t>
-            </a:r>
-          </a:p>
-          <a:p>
-            <a:pPr lvl="2"/>
-            <a:r>
-              <a:rPr lang="en-US"/>
-              <a:t>Third level</a:t>
-            </a:r>
-          </a:p>
-          <a:p>
-            <a:pPr lvl="3"/>
-            <a:r>
-              <a:rPr lang="en-US"/>
-              <a:t>Fourth level</a:t>
-            </a:r>
-          </a:p>
-          <a:p>
-            <a:pPr lvl="4"/>
-            <a:r>
-              <a:rPr lang="en-US"/>
-              <a:t>Fifth level</a:t>
-            </a:r>
-          </a:p>
-        </p:txBody>
-      </p:sp>
-      <p:sp>
-        <p:nvSpPr>
-          <p:cNvPr id="6" name="Footer Placeholder 5"/>
-          <p:cNvSpPr>
-            <a:spLocks noGrp="1"/>
-          </p:cNvSpPr>
-          <p:nvPr>
-            <p:ph type="ftr" sz="quarter" idx="4"/>
-          </p:nvPr>
-        </p:nvSpPr>
-        <p:spPr>
-          <a:xfrm>
-            <a:off x="0" y="8685213"/>
-            <a:ext cx="2971800" cy="458787"/>
-          </a:xfrm>
-          <a:prstGeom prst="rect">
-            <a:avLst/>
-          </a:prstGeom>
-        </p:spPr>
-        <p:txBody>
-          <a:bodyPr vert="horz" lIns="91440" tIns="45720" rIns="91440" bIns="45720" rtlCol="0" anchor="b"/>
-          <a:lstStyle>
-            <a:lvl1pPr algn="l">
-              <a:defRPr sz="1200"/>
-            </a:lvl1pPr>
-          </a:lstStyle>
-          <a:p>
-            <a:endParaRPr lang="en-US"/>
-          </a:p>
-        </p:txBody>
-      </p:sp>
-      <p:sp>
-        <p:nvSpPr>
-          <p:cNvPr id="7" name="Slide Number Placeholder 6"/>
-          <p:cNvSpPr>
-            <a:spLocks noGrp="1"/>
-          </p:cNvSpPr>
-          <p:nvPr>
-            <p:ph type="sldNum" sz="quarter" idx="5"/>
-          </p:nvPr>
-        </p:nvSpPr>
-        <p:spPr>
-          <a:xfrm>
-            <a:off x="3884613" y="8685213"/>
-            <a:ext cx="2971800" cy="458787"/>
-          </a:xfrm>
-          <a:prstGeom prst="rect">
-            <a:avLst/>
-          </a:prstGeom>
-        </p:spPr>
-        <p:txBody>
-          <a:bodyPr vert="horz" lIns="91440" tIns="45720" rIns="91440" bIns="45720" rtlCol="0" anchor="b"/>
-          <a:lstStyle>
-            <a:lvl1pPr algn="r">
-              <a:defRPr sz="1200"/>
-            </a:lvl1pPr>
-          </a:lstStyle>
-          <a:p>
-            <a:fld id="{CE5E9CC1-C706-0F49-92D6-E571CC5EEA8F}" type="slidenum">
-              <a:rPr lang="en-US"/>
-              <a:t>‹#›</a:t>
-            </a:fld>
-            <a:endParaRPr lang="en-US"/>
-          </a:p>
-        </p:txBody>
-      </p:sp>
     </p:spTree>
     <p:extLst>
       <p:ext uri="{BB962C8B-B14F-4D97-AF65-F5344CB8AC3E}">
-        <p14:creationId xmlns:p14="http://schemas.microsoft.com/office/powerpoint/2010/main" val="1024086991"/>
+        <p14:creationId xmlns:p14="http://schemas.microsoft.com/office/powerpoint/2010/main" val="1832213711"/>
       </p:ext>
     </p:extLst>
   </p:cSld>
@@ -512,10 +293,6 @@
           <a:bodyPr/>
           <a:lstStyle/>
           <a:p>
-            <a:r>
-              <a:rPr lang="en-US" dirty="0"/>
-              <a:t/>
-            </a:r>
             <a:endParaRPr lang="en-US" dirty="0"/>
           </a:p>
         </p:txBody>
@@ -600,10 +377,6 @@
           <a:bodyPr/>
           <a:lstStyle/>
           <a:p>
-            <a:r>
-              <a:rPr lang="en-US" dirty="0"/>
-              <a:t/>
-            </a:r>
             <a:endParaRPr lang="en-US" dirty="0"/>
           </a:p>
         </p:txBody>
@@ -688,10 +461,6 @@
           <a:bodyPr/>
           <a:lstStyle/>
           <a:p>
-            <a:r>
-              <a:rPr lang="en-US" dirty="0"/>
-              <a:t/>
-            </a:r>
             <a:endParaRPr lang="en-US" dirty="0"/>
           </a:p>
         </p:txBody>
@@ -776,10 +545,6 @@
           <a:bodyPr/>
           <a:lstStyle/>
           <a:p>
-            <a:r>
-              <a:rPr lang="en-US" dirty="0"/>
-              <a:t/>
-            </a:r>
             <a:endParaRPr lang="en-US" dirty="0"/>
           </a:p>
         </p:txBody>
@@ -864,10 +629,6 @@
           <a:bodyPr/>
           <a:lstStyle/>
           <a:p>
-            <a:r>
-              <a:rPr lang="en-US" dirty="0"/>
-              <a:t/>
-            </a:r>
             <a:endParaRPr lang="en-US" dirty="0"/>
           </a:p>
         </p:txBody>
@@ -952,10 +713,6 @@
           <a:bodyPr/>
           <a:lstStyle/>
           <a:p>
-            <a:r>
-              <a:rPr lang="en-US" dirty="0"/>
-              <a:t/>
-            </a:r>
             <a:endParaRPr lang="en-US" dirty="0"/>
           </a:p>
         </p:txBody>
@@ -1040,10 +797,6 @@
           <a:bodyPr/>
           <a:lstStyle/>
           <a:p>
-            <a:r>
-              <a:rPr lang="en-US" dirty="0"/>
-              <a:t/>
-            </a:r>
             <a:endParaRPr lang="en-US" dirty="0"/>
           </a:p>
         </p:txBody>
@@ -1128,10 +881,6 @@
           <a:bodyPr/>
           <a:lstStyle/>
           <a:p>
-            <a:r>
-              <a:rPr lang="en-US" dirty="0"/>
-              <a:t/>
-            </a:r>
             <a:endParaRPr lang="en-US" dirty="0"/>
           </a:p>
         </p:txBody>
@@ -1216,10 +965,6 @@
           <a:bodyPr/>
           <a:lstStyle/>
           <a:p>
-            <a:r>
-              <a:rPr lang="en-US" dirty="0"/>
-              <a:t/>
-            </a:r>
             <a:endParaRPr lang="en-US" dirty="0"/>
           </a:p>
         </p:txBody>
@@ -1304,10 +1049,6 @@
           <a:bodyPr/>
           <a:lstStyle/>
           <a:p>
-            <a:r>
-              <a:rPr lang="en-US" dirty="0"/>
-              <a:t/>
-            </a:r>
             <a:endParaRPr lang="en-US" dirty="0"/>
           </a:p>
         </p:txBody>
@@ -1392,10 +1133,6 @@
           <a:bodyPr/>
           <a:lstStyle/>
           <a:p>
-            <a:r>
-              <a:rPr lang="en-US" dirty="0"/>
-              <a:t/>
-            </a:r>
             <a:endParaRPr lang="en-US" dirty="0"/>
           </a:p>
         </p:txBody>
@@ -1480,10 +1217,6 @@
           <a:bodyPr/>
           <a:lstStyle/>
           <a:p>
-            <a:r>
-              <a:rPr lang="en-US" dirty="0"/>
-              <a:t/>
-            </a:r>
             <a:endParaRPr lang="en-US" dirty="0"/>
           </a:p>
         </p:txBody>
@@ -1568,10 +1301,6 @@
           <a:bodyPr/>
           <a:lstStyle/>
           <a:p>
-            <a:r>
-              <a:rPr lang="en-US" dirty="0"/>
-              <a:t/>
-            </a:r>
             <a:endParaRPr lang="en-US" dirty="0"/>
           </a:p>
         </p:txBody>
@@ -1645,6 +1374,11 @@
 <file path=ppt/slideMasters/slideMaster1.xml><?xml version="1.0" encoding="utf-8"?>
 <p:sldMaster xmlns:a="http://schemas.openxmlformats.org/drawingml/2006/main" xmlns:r="http://schemas.openxmlformats.org/officeDocument/2006/relationships" xmlns:p="http://schemas.openxmlformats.org/presentationml/2006/main">
   <p:cSld>
+    <p:bg>
+      <p:bgRef idx="1001">
+        <a:schemeClr val="bg1"/>
+      </p:bgRef>
+    </p:bg>
     <p:spTree>
       <p:nvGrpSpPr>
         <p:cNvPr id="1" name=""/>
@@ -1924,9 +1658,16 @@
   <p:cSld name="Slide 1">
     <p:bg>
       <p:bgPr>
-        <a:solidFill>
-          <a:srgbClr val="023047"/>
-        </a:solidFill>
+        <a:blipFill dpi="0" rotWithShape="1">
+          <a:blip r:embed="rId3">
+            <a:lum/>
+          </a:blip>
+          <a:srcRect/>
+          <a:stretch>
+            <a:fillRect l="-198000" r="-198000"/>
+          </a:stretch>
+        </a:blipFill>
+        <a:effectLst/>
       </p:bgPr>
     </p:bg>
     <p:spTree>
@@ -1962,6 +1703,13 @@
           </a:solidFill>
           <a:ln/>
         </p:spPr>
+        <p:txBody>
+          <a:bodyPr/>
+          <a:lstStyle/>
+          <a:p>
+            <a:endParaRPr lang="zh-CN" altLang="en-US"/>
+          </a:p>
+        </p:txBody>
       </p:sp>
       <p:sp>
         <p:nvSpPr>
@@ -1982,6 +1730,13 @@
           </a:solidFill>
           <a:ln/>
         </p:spPr>
+        <p:txBody>
+          <a:bodyPr/>
+          <a:lstStyle/>
+          <a:p>
+            <a:endParaRPr lang="zh-CN" altLang="en-US"/>
+          </a:p>
+        </p:txBody>
       </p:sp>
       <p:sp>
         <p:nvSpPr>
@@ -2002,6 +1757,13 @@
           </a:solidFill>
           <a:ln/>
         </p:spPr>
+        <p:txBody>
+          <a:bodyPr/>
+          <a:lstStyle/>
+          <a:p>
+            <a:endParaRPr lang="zh-CN" altLang="en-US"/>
+          </a:p>
+        </p:txBody>
       </p:sp>
       <p:sp>
         <p:nvSpPr>
@@ -2022,6 +1784,13 @@
           </a:solidFill>
           <a:ln/>
         </p:spPr>
+        <p:txBody>
+          <a:bodyPr/>
+          <a:lstStyle/>
+          <a:p>
+            <a:endParaRPr lang="zh-CN" altLang="en-US"/>
+          </a:p>
+        </p:txBody>
       </p:sp>
       <p:sp>
         <p:nvSpPr>
@@ -2042,6 +1811,13 @@
           </a:solidFill>
           <a:ln/>
         </p:spPr>
+        <p:txBody>
+          <a:bodyPr/>
+          <a:lstStyle/>
+          <a:p>
+            <a:endParaRPr lang="zh-CN" altLang="en-US"/>
+          </a:p>
+        </p:txBody>
       </p:sp>
       <p:sp>
         <p:nvSpPr>
@@ -2064,7 +1840,7 @@
           <a:bodyPr wrap="square" rtlCol="0" anchor="b"/>
           <a:lstStyle/>
           <a:p>
-            <a:pPr algn="l" indent="0" marL="0">
+            <a:pPr marL="0" indent="0" algn="l">
               <a:buNone/>
             </a:pPr>
             <a:r>
@@ -2103,7 +1879,7 @@
           <a:bodyPr wrap="square" rtlCol="0" anchor="t"/>
           <a:lstStyle/>
           <a:p>
-            <a:pPr algn="l" indent="0" marL="0">
+            <a:pPr marL="0" indent="0" algn="l">
               <a:buNone/>
             </a:pPr>
             <a:r>
@@ -2140,6 +1916,13 @@
           </a:solidFill>
           <a:ln/>
         </p:spPr>
+        <p:txBody>
+          <a:bodyPr/>
+          <a:lstStyle/>
+          <a:p>
+            <a:endParaRPr lang="zh-CN" altLang="en-US"/>
+          </a:p>
+        </p:txBody>
       </p:sp>
       <p:sp>
         <p:nvSpPr>
@@ -2162,7 +1945,7 @@
           <a:bodyPr wrap="square" rtlCol="0" anchor="ctr"/>
           <a:lstStyle/>
           <a:p>
-            <a:pPr algn="l" indent="0" marL="0">
+            <a:pPr marL="0" indent="0" algn="l">
               <a:buNone/>
             </a:pPr>
             <a:r>
@@ -2174,7 +1957,18 @@
                 <a:ea typeface="Microsoft YaHei" pitchFamily="34" charset="-122"/>
                 <a:cs typeface="Microsoft YaHei" pitchFamily="34" charset="-120"/>
               </a:rPr>
-              <a:t>让医学AI触手可及 — 从图像分析到科研全流程智能化</a:t>
+              <a:t>让医学AI触手可及 — </a:t>
+            </a:r>
+            <a:r>
+              <a:rPr lang="en-US" sz="1600" dirty="0" err="1">
+                <a:solidFill>
+                  <a:srgbClr val="8ECAE6"/>
+                </a:solidFill>
+                <a:latin typeface="Microsoft YaHei" pitchFamily="34" charset="0"/>
+                <a:ea typeface="Microsoft YaHei" pitchFamily="34" charset="-122"/>
+                <a:cs typeface="Microsoft YaHei" pitchFamily="34" charset="-120"/>
+              </a:rPr>
+              <a:t>从图像分析到科研全流程智能化</a:t>
             </a:r>
             <a:endParaRPr lang="en-US" sz="1600" dirty="0"/>
           </a:p>
@@ -2201,7 +1995,7 @@
           <a:bodyPr wrap="square" rtlCol="0" anchor="ctr"/>
           <a:lstStyle/>
           <a:p>
-            <a:pPr algn="l" indent="0" marL="0">
+            <a:pPr marL="0" indent="0" algn="l">
               <a:buNone/>
             </a:pPr>
             <a:r>
@@ -2216,6 +2010,53 @@
               <a:t>2026年6月  |  项目开发案例展示</a:t>
             </a:r>
             <a:endParaRPr lang="en-US" sz="1300" dirty="0"/>
+          </a:p>
+        </p:txBody>
+      </p:sp>
+      <p:sp>
+        <p:nvSpPr>
+          <p:cNvPr id="12" name="Text 8">
+            <a:extLst>
+              <a:ext uri="{FF2B5EF4-FFF2-40B4-BE49-F238E27FC236}">
+                <a16:creationId xmlns:a16="http://schemas.microsoft.com/office/drawing/2014/main" id="{0CFF3A2A-38B8-17A1-FA27-43461003339C}"/>
+              </a:ext>
+            </a:extLst>
+          </p:cNvPr>
+          <p:cNvSpPr/>
+          <p:nvPr/>
+        </p:nvSpPr>
+        <p:spPr>
+          <a:xfrm>
+            <a:off x="2966225" y="3619686"/>
+            <a:ext cx="5943600" cy="548640"/>
+          </a:xfrm>
+          <a:prstGeom prst="rect">
+            <a:avLst/>
+          </a:prstGeom>
+          <a:noFill/>
+          <a:ln/>
+        </p:spPr>
+        <p:txBody>
+          <a:bodyPr wrap="square" rtlCol="0" anchor="ctr"/>
+          <a:lstStyle/>
+          <a:p>
+            <a:r>
+              <a:rPr lang="zh-CN" altLang="en-US" sz="1600" dirty="0">
+                <a:solidFill>
+                  <a:srgbClr val="8ECAE6"/>
+                </a:solidFill>
+                <a:latin typeface="Microsoft YaHei" pitchFamily="34" charset="0"/>
+                <a:ea typeface="Microsoft YaHei" pitchFamily="34" charset="-122"/>
+              </a:rPr>
+              <a:t>开发人：周典</a:t>
+            </a:r>
+            <a:endParaRPr lang="en-US" altLang="zh-CN" sz="1600" dirty="0">
+              <a:solidFill>
+                <a:srgbClr val="8ECAE6"/>
+              </a:solidFill>
+              <a:latin typeface="Microsoft YaHei" pitchFamily="34" charset="0"/>
+              <a:ea typeface="Microsoft YaHei" pitchFamily="34" charset="-122"/>
+            </a:endParaRPr>
           </a:p>
         </p:txBody>
       </p:sp>
@@ -2235,6 +2076,7 @@
         <a:solidFill>
           <a:srgbClr val="023047"/>
         </a:solidFill>
+        <a:effectLst/>
       </p:bgPr>
     </p:bg>
     <p:spTree>
@@ -2270,6 +2112,13 @@
           </a:solidFill>
           <a:ln/>
         </p:spPr>
+        <p:txBody>
+          <a:bodyPr/>
+          <a:lstStyle/>
+          <a:p>
+            <a:endParaRPr lang="zh-CN" altLang="en-US"/>
+          </a:p>
+        </p:txBody>
       </p:sp>
       <p:sp>
         <p:nvSpPr>
@@ -2292,7 +2141,7 @@
           <a:bodyPr wrap="square" rtlCol="0" anchor="ctr"/>
           <a:lstStyle/>
           <a:p>
-            <a:pPr indent="0" marL="0">
+            <a:pPr marL="0" indent="0">
               <a:buNone/>
             </a:pPr>
             <a:r>
@@ -2331,17 +2180,24 @@
           </a:solidFill>
           <a:ln/>
         </p:spPr>
+        <p:txBody>
+          <a:bodyPr/>
+          <a:lstStyle/>
+          <a:p>
+            <a:endParaRPr lang="zh-CN" altLang="en-US"/>
+          </a:p>
+        </p:txBody>
       </p:sp>
       <p:pic>
         <p:nvPicPr>
-          <p:cNvPr id="5" name="Image 0" descr="F:\demo\slides\imgs\ui_06_learning.png">    </p:cNvPr>
+          <p:cNvPr id="5" name="Image 0" descr="F:\demo\slides\imgs\ui_06_learning.png"/>
           <p:cNvPicPr>
             <a:picLocks noChangeAspect="1"/>
           </p:cNvPicPr>
           <p:nvPr/>
         </p:nvPicPr>
         <p:blipFill>
-          <a:blip r:embed="rId1"/>
+          <a:blip r:embed="rId3"/>
           <a:stretch>
             <a:fillRect/>
           </a:stretch>
@@ -2375,6 +2231,13 @@
           </a:solidFill>
           <a:ln/>
         </p:spPr>
+        <p:txBody>
+          <a:bodyPr/>
+          <a:lstStyle/>
+          <a:p>
+            <a:endParaRPr lang="zh-CN" altLang="en-US"/>
+          </a:p>
+        </p:txBody>
       </p:sp>
       <p:sp>
         <p:nvSpPr>
@@ -2397,7 +2260,7 @@
           <a:bodyPr wrap="square" rtlCol="0" anchor="ctr"/>
           <a:lstStyle/>
           <a:p>
-            <a:pPr algn="ctr" indent="0" marL="0">
+            <a:pPr marL="0" indent="0" algn="ctr">
               <a:buNone/>
             </a:pPr>
             <a:r>
@@ -2431,6 +2294,7 @@
         <a:solidFill>
           <a:srgbClr val="FFFFFF"/>
         </a:solidFill>
+        <a:effectLst/>
       </p:bgPr>
     </p:bg>
     <p:spTree>
@@ -2466,6 +2330,13 @@
           </a:solidFill>
           <a:ln/>
         </p:spPr>
+        <p:txBody>
+          <a:bodyPr/>
+          <a:lstStyle/>
+          <a:p>
+            <a:endParaRPr lang="zh-CN" altLang="en-US"/>
+          </a:p>
+        </p:txBody>
       </p:sp>
       <p:sp>
         <p:nvSpPr>
@@ -2488,7 +2359,7 @@
           <a:bodyPr wrap="square" rtlCol="0" anchor="ctr"/>
           <a:lstStyle/>
           <a:p>
-            <a:pPr indent="0" marL="0">
+            <a:pPr marL="0" indent="0">
               <a:buNone/>
             </a:pPr>
             <a:r>
@@ -2527,6 +2398,13 @@
           </a:solidFill>
           <a:ln/>
         </p:spPr>
+        <p:txBody>
+          <a:bodyPr/>
+          <a:lstStyle/>
+          <a:p>
+            <a:endParaRPr lang="zh-CN" altLang="en-US"/>
+          </a:p>
+        </p:txBody>
       </p:sp>
       <p:sp>
         <p:nvSpPr>
@@ -2549,7 +2427,7 @@
           <a:bodyPr wrap="square" rtlCol="0" anchor="ctr"/>
           <a:lstStyle/>
           <a:p>
-            <a:pPr algn="ctr" indent="0" marL="0">
+            <a:pPr marL="0" indent="0" algn="ctr">
               <a:buNone/>
             </a:pPr>
             <a:r>
@@ -2588,6 +2466,13 @@
           </a:solidFill>
           <a:ln/>
         </p:spPr>
+        <p:txBody>
+          <a:bodyPr/>
+          <a:lstStyle/>
+          <a:p>
+            <a:endParaRPr lang="zh-CN" altLang="en-US"/>
+          </a:p>
+        </p:txBody>
       </p:sp>
       <p:sp>
         <p:nvSpPr>
@@ -2610,7 +2495,7 @@
           <a:bodyPr wrap="square" rtlCol="0" anchor="ctr"/>
           <a:lstStyle/>
           <a:p>
-            <a:pPr indent="0" marL="0">
+            <a:pPr marL="0" indent="0">
               <a:buNone/>
             </a:pPr>
             <a:r>
@@ -2649,6 +2534,13 @@
           </a:solidFill>
           <a:ln/>
         </p:spPr>
+        <p:txBody>
+          <a:bodyPr/>
+          <a:lstStyle/>
+          <a:p>
+            <a:endParaRPr lang="zh-CN" altLang="en-US"/>
+          </a:p>
+        </p:txBody>
       </p:sp>
       <p:sp>
         <p:nvSpPr>
@@ -2671,7 +2563,7 @@
           <a:bodyPr wrap="square" rtlCol="0" anchor="ctr"/>
           <a:lstStyle/>
           <a:p>
-            <a:pPr algn="ctr" indent="0" marL="0">
+            <a:pPr marL="0" indent="0" algn="ctr">
               <a:buNone/>
             </a:pPr>
             <a:r>
@@ -2710,6 +2602,13 @@
           </a:solidFill>
           <a:ln/>
         </p:spPr>
+        <p:txBody>
+          <a:bodyPr/>
+          <a:lstStyle/>
+          <a:p>
+            <a:endParaRPr lang="zh-CN" altLang="en-US"/>
+          </a:p>
+        </p:txBody>
       </p:sp>
       <p:sp>
         <p:nvSpPr>
@@ -2732,7 +2631,7 @@
           <a:bodyPr wrap="square" rtlCol="0" anchor="ctr"/>
           <a:lstStyle/>
           <a:p>
-            <a:pPr indent="0" marL="0">
+            <a:pPr marL="0" indent="0">
               <a:buNone/>
             </a:pPr>
             <a:r>
@@ -2771,6 +2670,13 @@
           </a:solidFill>
           <a:ln/>
         </p:spPr>
+        <p:txBody>
+          <a:bodyPr/>
+          <a:lstStyle/>
+          <a:p>
+            <a:endParaRPr lang="zh-CN" altLang="en-US"/>
+          </a:p>
+        </p:txBody>
       </p:sp>
       <p:sp>
         <p:nvSpPr>
@@ -2793,7 +2699,7 @@
           <a:bodyPr wrap="square" rtlCol="0" anchor="ctr"/>
           <a:lstStyle/>
           <a:p>
-            <a:pPr algn="ctr" indent="0" marL="0">
+            <a:pPr marL="0" indent="0" algn="ctr">
               <a:buNone/>
             </a:pPr>
             <a:r>
@@ -2832,6 +2738,13 @@
           </a:solidFill>
           <a:ln/>
         </p:spPr>
+        <p:txBody>
+          <a:bodyPr/>
+          <a:lstStyle/>
+          <a:p>
+            <a:endParaRPr lang="zh-CN" altLang="en-US"/>
+          </a:p>
+        </p:txBody>
       </p:sp>
       <p:sp>
         <p:nvSpPr>
@@ -2854,7 +2767,7 @@
           <a:bodyPr wrap="square" rtlCol="0" anchor="ctr"/>
           <a:lstStyle/>
           <a:p>
-            <a:pPr indent="0" marL="0">
+            <a:pPr marL="0" indent="0">
               <a:buNone/>
             </a:pPr>
             <a:r>
@@ -2893,6 +2806,13 @@
           </a:solidFill>
           <a:ln/>
         </p:spPr>
+        <p:txBody>
+          <a:bodyPr/>
+          <a:lstStyle/>
+          <a:p>
+            <a:endParaRPr lang="zh-CN" altLang="en-US"/>
+          </a:p>
+        </p:txBody>
       </p:sp>
       <p:sp>
         <p:nvSpPr>
@@ -2915,7 +2835,7 @@
           <a:bodyPr wrap="square" rtlCol="0" anchor="ctr"/>
           <a:lstStyle/>
           <a:p>
-            <a:pPr algn="ctr" indent="0" marL="0">
+            <a:pPr marL="0" indent="0" algn="ctr">
               <a:buNone/>
             </a:pPr>
             <a:r>
@@ -2954,6 +2874,13 @@
           </a:solidFill>
           <a:ln/>
         </p:spPr>
+        <p:txBody>
+          <a:bodyPr/>
+          <a:lstStyle/>
+          <a:p>
+            <a:endParaRPr lang="zh-CN" altLang="en-US"/>
+          </a:p>
+        </p:txBody>
       </p:sp>
       <p:sp>
         <p:nvSpPr>
@@ -2976,7 +2903,7 @@
           <a:bodyPr wrap="square" rtlCol="0" anchor="ctr"/>
           <a:lstStyle/>
           <a:p>
-            <a:pPr indent="0" marL="0">
+            <a:pPr marL="0" indent="0">
               <a:buNone/>
             </a:pPr>
             <a:r>
@@ -3013,6 +2940,13 @@
           </a:solidFill>
           <a:ln/>
         </p:spPr>
+        <p:txBody>
+          <a:bodyPr/>
+          <a:lstStyle/>
+          <a:p>
+            <a:endParaRPr lang="zh-CN" altLang="en-US"/>
+          </a:p>
+        </p:txBody>
       </p:sp>
       <p:sp>
         <p:nvSpPr>
@@ -3035,7 +2969,7 @@
           <a:bodyPr wrap="square" rtlCol="0" anchor="ctr"/>
           <a:lstStyle/>
           <a:p>
-            <a:pPr algn="ctr" indent="0" marL="0">
+            <a:pPr marL="0" indent="0" algn="ctr">
               <a:buNone/>
             </a:pPr>
             <a:r>
@@ -3074,7 +3008,7 @@
           <a:bodyPr wrap="square" rtlCol="0" anchor="ctr"/>
           <a:lstStyle/>
           <a:p>
-            <a:pPr indent="0" marL="0">
+            <a:pPr marL="0" indent="0">
               <a:buNone/>
             </a:pPr>
             <a:r>
@@ -3113,7 +3047,7 @@
           <a:bodyPr wrap="square" rtlCol="0" anchor="ctr"/>
           <a:lstStyle/>
           <a:p>
-            <a:pPr indent="0" marL="0">
+            <a:pPr marL="0" indent="0">
               <a:buNone/>
             </a:pPr>
             <a:r>
@@ -3152,7 +3086,7 @@
           <a:bodyPr wrap="square" rtlCol="0" anchor="ctr"/>
           <a:lstStyle/>
           <a:p>
-            <a:pPr algn="ctr" indent="0" marL="0">
+            <a:pPr marL="0" indent="0" algn="ctr">
               <a:buNone/>
             </a:pPr>
             <a:r>
@@ -3191,7 +3125,7 @@
           <a:bodyPr wrap="square" rtlCol="0" anchor="ctr"/>
           <a:lstStyle/>
           <a:p>
-            <a:pPr indent="0" marL="0">
+            <a:pPr marL="0" indent="0">
               <a:buNone/>
             </a:pPr>
             <a:r>
@@ -3230,7 +3164,7 @@
           <a:bodyPr wrap="square" rtlCol="0" anchor="ctr"/>
           <a:lstStyle/>
           <a:p>
-            <a:pPr indent="0" marL="0">
+            <a:pPr marL="0" indent="0">
               <a:buNone/>
             </a:pPr>
             <a:r>
@@ -3269,7 +3203,7 @@
           <a:bodyPr wrap="square" rtlCol="0" anchor="ctr"/>
           <a:lstStyle/>
           <a:p>
-            <a:pPr algn="ctr" indent="0" marL="0">
+            <a:pPr marL="0" indent="0" algn="ctr">
               <a:buNone/>
             </a:pPr>
             <a:r>
@@ -3308,7 +3242,7 @@
           <a:bodyPr wrap="square" rtlCol="0" anchor="ctr"/>
           <a:lstStyle/>
           <a:p>
-            <a:pPr indent="0" marL="0">
+            <a:pPr marL="0" indent="0">
               <a:buNone/>
             </a:pPr>
             <a:r>
@@ -3347,7 +3281,7 @@
           <a:bodyPr wrap="square" rtlCol="0" anchor="ctr"/>
           <a:lstStyle/>
           <a:p>
-            <a:pPr indent="0" marL="0">
+            <a:pPr marL="0" indent="0">
               <a:buNone/>
             </a:pPr>
             <a:r>
@@ -3386,7 +3320,7 @@
           <a:bodyPr wrap="square" rtlCol="0" anchor="ctr"/>
           <a:lstStyle/>
           <a:p>
-            <a:pPr algn="ctr" indent="0" marL="0">
+            <a:pPr marL="0" indent="0" algn="ctr">
               <a:buNone/>
             </a:pPr>
             <a:r>
@@ -3425,7 +3359,7 @@
           <a:bodyPr wrap="square" rtlCol="0" anchor="ctr"/>
           <a:lstStyle/>
           <a:p>
-            <a:pPr indent="0" marL="0">
+            <a:pPr marL="0" indent="0">
               <a:buNone/>
             </a:pPr>
             <a:r>
@@ -3464,7 +3398,7 @@
           <a:bodyPr wrap="square" rtlCol="0" anchor="ctr"/>
           <a:lstStyle/>
           <a:p>
-            <a:pPr indent="0" marL="0">
+            <a:pPr marL="0" indent="0">
               <a:buNone/>
             </a:pPr>
             <a:r>
@@ -3503,7 +3437,7 @@
           <a:bodyPr wrap="square" rtlCol="0" anchor="ctr"/>
           <a:lstStyle/>
           <a:p>
-            <a:pPr algn="ctr" indent="0" marL="0">
+            <a:pPr marL="0" indent="0" algn="ctr">
               <a:buNone/>
             </a:pPr>
             <a:r>
@@ -3542,7 +3476,7 @@
           <a:bodyPr wrap="square" rtlCol="0" anchor="ctr"/>
           <a:lstStyle/>
           <a:p>
-            <a:pPr indent="0" marL="0">
+            <a:pPr marL="0" indent="0">
               <a:buNone/>
             </a:pPr>
             <a:r>
@@ -3581,7 +3515,7 @@
           <a:bodyPr wrap="square" rtlCol="0" anchor="ctr"/>
           <a:lstStyle/>
           <a:p>
-            <a:pPr indent="0" marL="0">
+            <a:pPr marL="0" indent="0">
               <a:buNone/>
             </a:pPr>
             <a:r>
@@ -3620,6 +3554,13 @@
           </a:solidFill>
           <a:ln/>
         </p:spPr>
+        <p:txBody>
+          <a:bodyPr/>
+          <a:lstStyle/>
+          <a:p>
+            <a:endParaRPr lang="zh-CN" altLang="en-US"/>
+          </a:p>
+        </p:txBody>
       </p:sp>
       <p:sp>
         <p:nvSpPr>
@@ -3642,7 +3583,7 @@
           <a:bodyPr wrap="square" rtlCol="0" anchor="ctr"/>
           <a:lstStyle/>
           <a:p>
-            <a:pPr algn="ctr" indent="0" marL="0">
+            <a:pPr marL="0" indent="0" algn="ctr">
               <a:buNone/>
             </a:pPr>
             <a:r>
@@ -3681,7 +3622,7 @@
           <a:bodyPr wrap="square" rtlCol="0" anchor="ctr"/>
           <a:lstStyle/>
           <a:p>
-            <a:pPr algn="ctr" indent="0" marL="0">
+            <a:pPr marL="0" indent="0" algn="ctr">
               <a:buNone/>
             </a:pPr>
             <a:r>
@@ -3720,7 +3661,7 @@
           <a:bodyPr wrap="square" rtlCol="0" anchor="ctr"/>
           <a:lstStyle/>
           <a:p>
-            <a:pPr algn="ctr" indent="0" marL="0">
+            <a:pPr marL="0" indent="0" algn="ctr">
               <a:buNone/>
             </a:pPr>
             <a:r>
@@ -3759,7 +3700,7 @@
           <a:bodyPr wrap="square" rtlCol="0" anchor="ctr"/>
           <a:lstStyle/>
           <a:p>
-            <a:pPr algn="ctr" indent="0" marL="0">
+            <a:pPr marL="0" indent="0" algn="ctr">
               <a:buNone/>
             </a:pPr>
             <a:r>
@@ -3798,7 +3739,7 @@
           <a:bodyPr wrap="square" rtlCol="0" anchor="ctr"/>
           <a:lstStyle/>
           <a:p>
-            <a:pPr algn="ctr" indent="0" marL="0">
+            <a:pPr marL="0" indent="0" algn="ctr">
               <a:buNone/>
             </a:pPr>
             <a:r>
@@ -3837,7 +3778,7 @@
           <a:bodyPr wrap="square" rtlCol="0" anchor="ctr"/>
           <a:lstStyle/>
           <a:p>
-            <a:pPr algn="ctr" indent="0" marL="0">
+            <a:pPr marL="0" indent="0" algn="ctr">
               <a:buNone/>
             </a:pPr>
             <a:r>
@@ -3876,7 +3817,7 @@
           <a:bodyPr wrap="square" rtlCol="0" anchor="ctr"/>
           <a:lstStyle/>
           <a:p>
-            <a:pPr algn="ctr" indent="0" marL="0">
+            <a:pPr marL="0" indent="0" algn="ctr">
               <a:buNone/>
             </a:pPr>
             <a:r>
@@ -3915,7 +3856,7 @@
           <a:bodyPr wrap="square" rtlCol="0" anchor="ctr"/>
           <a:lstStyle/>
           <a:p>
-            <a:pPr algn="ctr" indent="0" marL="0">
+            <a:pPr marL="0" indent="0" algn="ctr">
               <a:buNone/>
             </a:pPr>
             <a:r>
@@ -3954,7 +3895,7 @@
           <a:bodyPr wrap="square" rtlCol="0" anchor="ctr"/>
           <a:lstStyle/>
           <a:p>
-            <a:pPr algn="ctr" indent="0" marL="0">
+            <a:pPr marL="0" indent="0" algn="ctr">
               <a:buNone/>
             </a:pPr>
             <a:r>
@@ -3993,7 +3934,7 @@
           <a:bodyPr wrap="square" rtlCol="0" anchor="ctr"/>
           <a:lstStyle/>
           <a:p>
-            <a:pPr algn="ctr" indent="0" marL="0">
+            <a:pPr marL="0" indent="0" algn="ctr">
               <a:buNone/>
             </a:pPr>
             <a:r>
@@ -4030,6 +3971,13 @@
           </a:solidFill>
           <a:ln/>
         </p:spPr>
+        <p:txBody>
+          <a:bodyPr/>
+          <a:lstStyle/>
+          <a:p>
+            <a:endParaRPr lang="zh-CN" altLang="en-US"/>
+          </a:p>
+        </p:txBody>
       </p:sp>
       <p:sp>
         <p:nvSpPr>
@@ -4052,7 +4000,7 @@
           <a:bodyPr wrap="square" rtlCol="0" anchor="ctr"/>
           <a:lstStyle/>
           <a:p>
-            <a:pPr algn="ctr" indent="0" marL="0">
+            <a:pPr marL="0" indent="0" algn="ctr">
               <a:buNone/>
             </a:pPr>
             <a:r>
@@ -4086,6 +4034,7 @@
         <a:solidFill>
           <a:srgbClr val="023047"/>
         </a:solidFill>
+        <a:effectLst/>
       </p:bgPr>
     </p:bg>
     <p:spTree>
@@ -4121,6 +4070,13 @@
           </a:solidFill>
           <a:ln/>
         </p:spPr>
+        <p:txBody>
+          <a:bodyPr/>
+          <a:lstStyle/>
+          <a:p>
+            <a:endParaRPr lang="zh-CN" altLang="en-US"/>
+          </a:p>
+        </p:txBody>
       </p:sp>
       <p:sp>
         <p:nvSpPr>
@@ -4143,7 +4099,7 @@
           <a:bodyPr wrap="square" rtlCol="0" anchor="ctr"/>
           <a:lstStyle/>
           <a:p>
-            <a:pPr indent="0" marL="0">
+            <a:pPr marL="0" indent="0">
               <a:buNone/>
             </a:pPr>
             <a:r>
@@ -4182,6 +4138,13 @@
           </a:solidFill>
           <a:ln/>
         </p:spPr>
+        <p:txBody>
+          <a:bodyPr/>
+          <a:lstStyle/>
+          <a:p>
+            <a:endParaRPr lang="zh-CN" altLang="en-US"/>
+          </a:p>
+        </p:txBody>
       </p:sp>
       <p:sp>
         <p:nvSpPr>
@@ -4204,7 +4167,7 @@
           <a:bodyPr wrap="square" rtlCol="0" anchor="ctr"/>
           <a:lstStyle/>
           <a:p>
-            <a:pPr algn="ctr" indent="0" marL="0">
+            <a:pPr marL="0" indent="0" algn="ctr">
               <a:buNone/>
             </a:pPr>
             <a:r>
@@ -4243,7 +4206,7 @@
           <a:bodyPr wrap="square" rtlCol="0" anchor="ctr"/>
           <a:lstStyle/>
           <a:p>
-            <a:pPr algn="ctr" indent="0" marL="0">
+            <a:pPr marL="0" indent="0" algn="ctr">
               <a:buNone/>
             </a:pPr>
             <a:r>
@@ -4282,7 +4245,7 @@
           <a:bodyPr wrap="square" rtlCol="0" anchor="ctr"/>
           <a:lstStyle/>
           <a:p>
-            <a:pPr algn="ctr" indent="0" marL="0">
+            <a:pPr marL="0" indent="0" algn="ctr">
               <a:lnSpc>
                 <a:spcPct val="140000"/>
               </a:lnSpc>
@@ -4302,7 +4265,7 @@
             <a:endParaRPr lang="en-US" sz="1000" dirty="0"/>
           </a:p>
           <a:p>
-            <a:pPr algn="ctr" indent="0" marL="0">
+            <a:pPr marL="0" indent="0" algn="ctr">
               <a:lnSpc>
                 <a:spcPct val="140000"/>
               </a:lnSpc>
@@ -4344,6 +4307,13 @@
           </a:solidFill>
           <a:ln/>
         </p:spPr>
+        <p:txBody>
+          <a:bodyPr/>
+          <a:lstStyle/>
+          <a:p>
+            <a:endParaRPr lang="zh-CN" altLang="en-US"/>
+          </a:p>
+        </p:txBody>
       </p:sp>
       <p:sp>
         <p:nvSpPr>
@@ -4366,7 +4336,7 @@
           <a:bodyPr wrap="square" rtlCol="0" anchor="ctr"/>
           <a:lstStyle/>
           <a:p>
-            <a:pPr algn="ctr" indent="0" marL="0">
+            <a:pPr marL="0" indent="0" algn="ctr">
               <a:buNone/>
             </a:pPr>
             <a:r>
@@ -4405,7 +4375,7 @@
           <a:bodyPr wrap="square" rtlCol="0" anchor="ctr"/>
           <a:lstStyle/>
           <a:p>
-            <a:pPr algn="ctr" indent="0" marL="0">
+            <a:pPr marL="0" indent="0" algn="ctr">
               <a:buNone/>
             </a:pPr>
             <a:r>
@@ -4444,7 +4414,7 @@
           <a:bodyPr wrap="square" rtlCol="0" anchor="ctr"/>
           <a:lstStyle/>
           <a:p>
-            <a:pPr algn="ctr" indent="0" marL="0">
+            <a:pPr marL="0" indent="0" algn="ctr">
               <a:lnSpc>
                 <a:spcPct val="140000"/>
               </a:lnSpc>
@@ -4464,7 +4434,7 @@
             <a:endParaRPr lang="en-US" sz="1000" dirty="0"/>
           </a:p>
           <a:p>
-            <a:pPr algn="ctr" indent="0" marL="0">
+            <a:pPr marL="0" indent="0" algn="ctr">
               <a:lnSpc>
                 <a:spcPct val="140000"/>
               </a:lnSpc>
@@ -4506,6 +4476,13 @@
           </a:solidFill>
           <a:ln/>
         </p:spPr>
+        <p:txBody>
+          <a:bodyPr/>
+          <a:lstStyle/>
+          <a:p>
+            <a:endParaRPr lang="zh-CN" altLang="en-US"/>
+          </a:p>
+        </p:txBody>
       </p:sp>
       <p:sp>
         <p:nvSpPr>
@@ -4528,7 +4505,7 @@
           <a:bodyPr wrap="square" rtlCol="0" anchor="ctr"/>
           <a:lstStyle/>
           <a:p>
-            <a:pPr algn="ctr" indent="0" marL="0">
+            <a:pPr marL="0" indent="0" algn="ctr">
               <a:buNone/>
             </a:pPr>
             <a:r>
@@ -4567,7 +4544,7 @@
           <a:bodyPr wrap="square" rtlCol="0" anchor="ctr"/>
           <a:lstStyle/>
           <a:p>
-            <a:pPr algn="ctr" indent="0" marL="0">
+            <a:pPr marL="0" indent="0" algn="ctr">
               <a:buNone/>
             </a:pPr>
             <a:r>
@@ -4606,7 +4583,7 @@
           <a:bodyPr wrap="square" rtlCol="0" anchor="ctr"/>
           <a:lstStyle/>
           <a:p>
-            <a:pPr algn="ctr" indent="0" marL="0">
+            <a:pPr marL="0" indent="0" algn="ctr">
               <a:lnSpc>
                 <a:spcPct val="140000"/>
               </a:lnSpc>
@@ -4626,7 +4603,7 @@
             <a:endParaRPr lang="en-US" sz="1000" dirty="0"/>
           </a:p>
           <a:p>
-            <a:pPr algn="ctr" indent="0" marL="0">
+            <a:pPr marL="0" indent="0" algn="ctr">
               <a:lnSpc>
                 <a:spcPct val="140000"/>
               </a:lnSpc>
@@ -4668,6 +4645,13 @@
           </a:solidFill>
           <a:ln/>
         </p:spPr>
+        <p:txBody>
+          <a:bodyPr/>
+          <a:lstStyle/>
+          <a:p>
+            <a:endParaRPr lang="zh-CN" altLang="en-US"/>
+          </a:p>
+        </p:txBody>
       </p:sp>
       <p:sp>
         <p:nvSpPr>
@@ -4690,7 +4674,7 @@
           <a:bodyPr wrap="square" rtlCol="0" anchor="ctr"/>
           <a:lstStyle/>
           <a:p>
-            <a:pPr algn="ctr" indent="0" marL="0">
+            <a:pPr marL="0" indent="0" algn="ctr">
               <a:buNone/>
             </a:pPr>
             <a:r>
@@ -4729,7 +4713,7 @@
           <a:bodyPr wrap="square" rtlCol="0" anchor="ctr"/>
           <a:lstStyle/>
           <a:p>
-            <a:pPr algn="ctr" indent="0" marL="0">
+            <a:pPr marL="0" indent="0" algn="ctr">
               <a:buNone/>
             </a:pPr>
             <a:r>
@@ -4768,7 +4752,7 @@
           <a:bodyPr wrap="square" rtlCol="0" anchor="ctr"/>
           <a:lstStyle/>
           <a:p>
-            <a:pPr algn="ctr" indent="0" marL="0">
+            <a:pPr marL="0" indent="0" algn="ctr">
               <a:lnSpc>
                 <a:spcPct val="140000"/>
               </a:lnSpc>
@@ -4788,7 +4772,7 @@
             <a:endParaRPr lang="en-US" sz="1000" dirty="0"/>
           </a:p>
           <a:p>
-            <a:pPr algn="ctr" indent="0" marL="0">
+            <a:pPr marL="0" indent="0" algn="ctr">
               <a:lnSpc>
                 <a:spcPct val="140000"/>
               </a:lnSpc>
@@ -4830,6 +4814,13 @@
           </a:solidFill>
           <a:ln/>
         </p:spPr>
+        <p:txBody>
+          <a:bodyPr/>
+          <a:lstStyle/>
+          <a:p>
+            <a:endParaRPr lang="zh-CN" altLang="en-US"/>
+          </a:p>
+        </p:txBody>
       </p:sp>
       <p:sp>
         <p:nvSpPr>
@@ -4852,7 +4843,7 @@
           <a:bodyPr wrap="square" rtlCol="0" anchor="ctr"/>
           <a:lstStyle/>
           <a:p>
-            <a:pPr indent="0" marL="0">
+            <a:pPr marL="0" indent="0">
               <a:buNone/>
             </a:pPr>
             <a:r>
@@ -4891,7 +4882,7 @@
           <a:bodyPr wrap="square" rtlCol="0" anchor="ctr"/>
           <a:lstStyle/>
           <a:p>
-            <a:pPr indent="0" marL="0">
+            <a:pPr marL="0" indent="0">
               <a:buNone/>
             </a:pPr>
             <a:r>
@@ -4930,7 +4921,7 @@
           <a:bodyPr wrap="square" rtlCol="0" anchor="ctr"/>
           <a:lstStyle/>
           <a:p>
-            <a:pPr indent="0" marL="0">
+            <a:pPr marL="0" indent="0">
               <a:buNone/>
             </a:pPr>
             <a:r>
@@ -4969,7 +4960,7 @@
           <a:bodyPr wrap="square" rtlCol="0" anchor="ctr"/>
           <a:lstStyle/>
           <a:p>
-            <a:pPr indent="0" marL="0">
+            <a:pPr marL="0" indent="0">
               <a:buNone/>
             </a:pPr>
             <a:r>
@@ -5006,6 +4997,13 @@
           </a:solidFill>
           <a:ln/>
         </p:spPr>
+        <p:txBody>
+          <a:bodyPr/>
+          <a:lstStyle/>
+          <a:p>
+            <a:endParaRPr lang="zh-CN" altLang="en-US"/>
+          </a:p>
+        </p:txBody>
       </p:sp>
       <p:sp>
         <p:nvSpPr>
@@ -5028,7 +5026,7 @@
           <a:bodyPr wrap="square" rtlCol="0" anchor="ctr"/>
           <a:lstStyle/>
           <a:p>
-            <a:pPr algn="ctr" indent="0" marL="0">
+            <a:pPr marL="0" indent="0" algn="ctr">
               <a:buNone/>
             </a:pPr>
             <a:r>
@@ -5062,6 +5060,7 @@
         <a:solidFill>
           <a:srgbClr val="023047"/>
         </a:solidFill>
+        <a:effectLst/>
       </p:bgPr>
     </p:bg>
     <p:spTree>
@@ -5097,6 +5096,13 @@
           </a:solidFill>
           <a:ln/>
         </p:spPr>
+        <p:txBody>
+          <a:bodyPr/>
+          <a:lstStyle/>
+          <a:p>
+            <a:endParaRPr lang="zh-CN" altLang="en-US"/>
+          </a:p>
+        </p:txBody>
       </p:sp>
       <p:sp>
         <p:nvSpPr>
@@ -5117,6 +5123,13 @@
           </a:solidFill>
           <a:ln/>
         </p:spPr>
+        <p:txBody>
+          <a:bodyPr/>
+          <a:lstStyle/>
+          <a:p>
+            <a:endParaRPr lang="zh-CN" altLang="en-US"/>
+          </a:p>
+        </p:txBody>
       </p:sp>
       <p:sp>
         <p:nvSpPr>
@@ -5139,7 +5152,7 @@
           <a:bodyPr wrap="square" rtlCol="0" anchor="ctr"/>
           <a:lstStyle/>
           <a:p>
-            <a:pPr algn="ctr" indent="0" marL="0">
+            <a:pPr marL="0" indent="0" algn="ctr">
               <a:buNone/>
             </a:pPr>
             <a:r>
@@ -5176,6 +5189,13 @@
           </a:solidFill>
           <a:ln/>
         </p:spPr>
+        <p:txBody>
+          <a:bodyPr/>
+          <a:lstStyle/>
+          <a:p>
+            <a:endParaRPr lang="zh-CN" altLang="en-US"/>
+          </a:p>
+        </p:txBody>
       </p:sp>
       <p:sp>
         <p:nvSpPr>
@@ -5198,7 +5218,7 @@
           <a:bodyPr wrap="square" rtlCol="0" anchor="ctr"/>
           <a:lstStyle/>
           <a:p>
-            <a:pPr algn="ctr" indent="0" marL="0">
+            <a:pPr marL="0" indent="0" algn="ctr">
               <a:lnSpc>
                 <a:spcPct val="160000"/>
               </a:lnSpc>
@@ -5218,7 +5238,7 @@
             <a:endParaRPr lang="en-US" sz="1600" dirty="0"/>
           </a:p>
           <a:p>
-            <a:pPr algn="ctr" indent="0" marL="0">
+            <a:pPr marL="0" indent="0" algn="ctr">
               <a:lnSpc>
                 <a:spcPct val="160000"/>
               </a:lnSpc>
@@ -5260,7 +5280,7 @@
           <a:bodyPr wrap="square" rtlCol="0" anchor="ctr"/>
           <a:lstStyle/>
           <a:p>
-            <a:pPr algn="ctr" indent="0" marL="0">
+            <a:pPr marL="0" indent="0" algn="ctr">
               <a:buNone/>
             </a:pPr>
             <a:r>
@@ -5294,6 +5314,7 @@
         <a:solidFill>
           <a:srgbClr val="FFFFFF"/>
         </a:solidFill>
+        <a:effectLst/>
       </p:bgPr>
     </p:bg>
     <p:spTree>
@@ -5329,6 +5350,13 @@
           </a:solidFill>
           <a:ln/>
         </p:spPr>
+        <p:txBody>
+          <a:bodyPr/>
+          <a:lstStyle/>
+          <a:p>
+            <a:endParaRPr lang="zh-CN" altLang="en-US"/>
+          </a:p>
+        </p:txBody>
       </p:sp>
       <p:sp>
         <p:nvSpPr>
@@ -5351,6 +5379,13 @@
           </a:solidFill>
           <a:ln/>
         </p:spPr>
+        <p:txBody>
+          <a:bodyPr/>
+          <a:lstStyle/>
+          <a:p>
+            <a:endParaRPr lang="zh-CN" altLang="en-US"/>
+          </a:p>
+        </p:txBody>
       </p:sp>
       <p:sp>
         <p:nvSpPr>
@@ -5373,7 +5408,7 @@
           <a:bodyPr wrap="square" rtlCol="0" anchor="ctr"/>
           <a:lstStyle/>
           <a:p>
-            <a:pPr algn="ctr" indent="0" marL="0">
+            <a:pPr marL="0" indent="0" algn="ctr">
               <a:buNone/>
             </a:pPr>
             <a:r>
@@ -5412,7 +5447,7 @@
           <a:bodyPr wrap="square" rtlCol="0" anchor="ctr"/>
           <a:lstStyle/>
           <a:p>
-            <a:pPr indent="0" marL="0">
+            <a:pPr marL="0" indent="0">
               <a:buNone/>
             </a:pPr>
             <a:r>
@@ -5442,15 +5477,20 @@
             <a:ext cx="3931920" cy="2926080"/>
           </a:xfrm>
           <a:prstGeom prst="rect">
-            <a:avLst>
-              <a:gd name="adj" fmla="val 3125"/>
-            </a:avLst>
+            <a:avLst/>
           </a:prstGeom>
           <a:solidFill>
             <a:srgbClr val="F0F8FC"/>
           </a:solidFill>
           <a:ln/>
         </p:spPr>
+        <p:txBody>
+          <a:bodyPr/>
+          <a:lstStyle/>
+          <a:p>
+            <a:endParaRPr lang="zh-CN" altLang="en-US"/>
+          </a:p>
+        </p:txBody>
       </p:sp>
       <p:sp>
         <p:nvSpPr>
@@ -5473,7 +5513,7 @@
           <a:bodyPr wrap="square" rtlCol="0" anchor="ctr"/>
           <a:lstStyle/>
           <a:p>
-            <a:pPr indent="0" marL="0">
+            <a:pPr marL="0" indent="0">
               <a:buNone/>
             </a:pPr>
             <a:r>
@@ -5512,7 +5552,7 @@
           <a:bodyPr wrap="square" rtlCol="0" anchor="t"/>
           <a:lstStyle/>
           <a:p>
-            <a:pPr algn="l" indent="0" marL="0">
+            <a:pPr marL="0" indent="0" algn="l">
               <a:buNone/>
             </a:pPr>
             <a:r>
@@ -5551,7 +5591,7 @@
           <a:bodyPr wrap="square" rtlCol="0" anchor="t"/>
           <a:lstStyle/>
           <a:p>
-            <a:pPr algn="l" indent="0" marL="0">
+            <a:pPr marL="0" indent="0" algn="l">
               <a:buNone/>
             </a:pPr>
             <a:r>
@@ -5590,7 +5630,7 @@
           <a:bodyPr wrap="square" rtlCol="0" anchor="t"/>
           <a:lstStyle/>
           <a:p>
-            <a:pPr algn="l" indent="0" marL="0">
+            <a:pPr marL="0" indent="0" algn="l">
               <a:buNone/>
             </a:pPr>
             <a:r>
@@ -5629,7 +5669,7 @@
           <a:bodyPr wrap="square" rtlCol="0" anchor="t"/>
           <a:lstStyle/>
           <a:p>
-            <a:pPr algn="l" indent="0" marL="0">
+            <a:pPr marL="0" indent="0" algn="l">
               <a:buNone/>
             </a:pPr>
             <a:r>
@@ -5668,7 +5708,7 @@
           <a:bodyPr wrap="square" rtlCol="0" anchor="t"/>
           <a:lstStyle/>
           <a:p>
-            <a:pPr algn="l" indent="0" marL="0">
+            <a:pPr marL="0" indent="0" algn="l">
               <a:buNone/>
             </a:pPr>
             <a:r>
@@ -5707,7 +5747,7 @@
           <a:bodyPr wrap="square" rtlCol="0" anchor="t"/>
           <a:lstStyle/>
           <a:p>
-            <a:pPr algn="l" indent="0" marL="0">
+            <a:pPr marL="0" indent="0" algn="l">
               <a:buNone/>
             </a:pPr>
             <a:r>
@@ -5746,7 +5786,7 @@
           <a:bodyPr wrap="square" rtlCol="0" anchor="t"/>
           <a:lstStyle/>
           <a:p>
-            <a:pPr algn="l" indent="0" marL="0">
+            <a:pPr marL="0" indent="0" algn="l">
               <a:buNone/>
             </a:pPr>
             <a:r>
@@ -5785,7 +5825,7 @@
           <a:bodyPr wrap="square" rtlCol="0" anchor="t"/>
           <a:lstStyle/>
           <a:p>
-            <a:pPr algn="l" indent="0" marL="0">
+            <a:pPr marL="0" indent="0" algn="l">
               <a:buNone/>
             </a:pPr>
             <a:r>
@@ -5815,15 +5855,20 @@
             <a:ext cx="3931920" cy="2926080"/>
           </a:xfrm>
           <a:prstGeom prst="rect">
-            <a:avLst>
-              <a:gd name="adj" fmla="val 3125"/>
-            </a:avLst>
+            <a:avLst/>
           </a:prstGeom>
           <a:solidFill>
             <a:srgbClr val="023047"/>
           </a:solidFill>
           <a:ln/>
         </p:spPr>
+        <p:txBody>
+          <a:bodyPr/>
+          <a:lstStyle/>
+          <a:p>
+            <a:endParaRPr lang="zh-CN" altLang="en-US"/>
+          </a:p>
+        </p:txBody>
       </p:sp>
       <p:sp>
         <p:nvSpPr>
@@ -5846,7 +5891,7 @@
           <a:bodyPr wrap="square" rtlCol="0" anchor="ctr"/>
           <a:lstStyle/>
           <a:p>
-            <a:pPr indent="0" marL="0">
+            <a:pPr marL="0" indent="0">
               <a:buNone/>
             </a:pPr>
             <a:r>
@@ -5885,7 +5930,7 @@
           <a:bodyPr wrap="square" rtlCol="0" anchor="t"/>
           <a:lstStyle/>
           <a:p>
-            <a:pPr algn="ctr" indent="0" marL="0">
+            <a:pPr marL="0" indent="0" algn="ctr">
               <a:buNone/>
             </a:pPr>
             <a:r>
@@ -5924,7 +5969,7 @@
           <a:bodyPr wrap="square" rtlCol="0" anchor="t"/>
           <a:lstStyle/>
           <a:p>
-            <a:pPr indent="0" marL="0">
+            <a:pPr marL="0" indent="0">
               <a:buNone/>
             </a:pPr>
             <a:r>
@@ -5963,7 +6008,7 @@
           <a:bodyPr wrap="square" rtlCol="0" anchor="t"/>
           <a:lstStyle/>
           <a:p>
-            <a:pPr algn="ctr" indent="0" marL="0">
+            <a:pPr marL="0" indent="0" algn="ctr">
               <a:buNone/>
             </a:pPr>
             <a:r>
@@ -6002,7 +6047,7 @@
           <a:bodyPr wrap="square" rtlCol="0" anchor="t"/>
           <a:lstStyle/>
           <a:p>
-            <a:pPr indent="0" marL="0">
+            <a:pPr marL="0" indent="0">
               <a:buNone/>
             </a:pPr>
             <a:r>
@@ -6041,7 +6086,7 @@
           <a:bodyPr wrap="square" rtlCol="0" anchor="t"/>
           <a:lstStyle/>
           <a:p>
-            <a:pPr algn="ctr" indent="0" marL="0">
+            <a:pPr marL="0" indent="0" algn="ctr">
               <a:buNone/>
             </a:pPr>
             <a:r>
@@ -6080,7 +6125,7 @@
           <a:bodyPr wrap="square" rtlCol="0" anchor="t"/>
           <a:lstStyle/>
           <a:p>
-            <a:pPr indent="0" marL="0">
+            <a:pPr marL="0" indent="0">
               <a:buNone/>
             </a:pPr>
             <a:r>
@@ -6119,7 +6164,7 @@
           <a:bodyPr wrap="square" rtlCol="0" anchor="t"/>
           <a:lstStyle/>
           <a:p>
-            <a:pPr algn="ctr" indent="0" marL="0">
+            <a:pPr marL="0" indent="0" algn="ctr">
               <a:buNone/>
             </a:pPr>
             <a:r>
@@ -6158,7 +6203,7 @@
           <a:bodyPr wrap="square" rtlCol="0" anchor="t"/>
           <a:lstStyle/>
           <a:p>
-            <a:pPr indent="0" marL="0">
+            <a:pPr marL="0" indent="0">
               <a:buNone/>
             </a:pPr>
             <a:r>
@@ -6195,6 +6240,13 @@
           </a:solidFill>
           <a:ln/>
         </p:spPr>
+        <p:txBody>
+          <a:bodyPr/>
+          <a:lstStyle/>
+          <a:p>
+            <a:endParaRPr lang="zh-CN" altLang="en-US"/>
+          </a:p>
+        </p:txBody>
       </p:sp>
       <p:sp>
         <p:nvSpPr>
@@ -6217,7 +6269,7 @@
           <a:bodyPr wrap="square" rtlCol="0" anchor="ctr"/>
           <a:lstStyle/>
           <a:p>
-            <a:pPr algn="ctr" indent="0" marL="0">
+            <a:pPr marL="0" indent="0" algn="ctr">
               <a:buNone/>
             </a:pPr>
             <a:r>
@@ -6251,6 +6303,7 @@
         <a:solidFill>
           <a:srgbClr val="023047"/>
         </a:solidFill>
+        <a:effectLst/>
       </p:bgPr>
     </p:bg>
     <p:spTree>
@@ -6286,6 +6339,13 @@
           </a:solidFill>
           <a:ln/>
         </p:spPr>
+        <p:txBody>
+          <a:bodyPr/>
+          <a:lstStyle/>
+          <a:p>
+            <a:endParaRPr lang="zh-CN" altLang="en-US"/>
+          </a:p>
+        </p:txBody>
       </p:sp>
       <p:sp>
         <p:nvSpPr>
@@ -6306,6 +6366,13 @@
           </a:solidFill>
           <a:ln/>
         </p:spPr>
+        <p:txBody>
+          <a:bodyPr/>
+          <a:lstStyle/>
+          <a:p>
+            <a:endParaRPr lang="zh-CN" altLang="en-US"/>
+          </a:p>
+        </p:txBody>
       </p:sp>
       <p:sp>
         <p:nvSpPr>
@@ -6328,7 +6395,7 @@
           <a:bodyPr wrap="square" rtlCol="0" anchor="ctr"/>
           <a:lstStyle/>
           <a:p>
-            <a:pPr indent="0" marL="0">
+            <a:pPr marL="0" indent="0">
               <a:buNone/>
             </a:pPr>
             <a:r>
@@ -6367,7 +6434,7 @@
           <a:bodyPr wrap="square" rtlCol="0" anchor="ctr"/>
           <a:lstStyle/>
           <a:p>
-            <a:pPr indent="0" marL="0">
+            <a:pPr marL="0" indent="0">
               <a:buNone/>
             </a:pPr>
             <a:r>
@@ -6404,6 +6471,13 @@
           </a:solidFill>
           <a:ln/>
         </p:spPr>
+        <p:txBody>
+          <a:bodyPr/>
+          <a:lstStyle/>
+          <a:p>
+            <a:endParaRPr lang="zh-CN" altLang="en-US"/>
+          </a:p>
+        </p:txBody>
       </p:sp>
       <p:sp>
         <p:nvSpPr>
@@ -6426,7 +6500,7 @@
           <a:bodyPr wrap="square" rtlCol="0" anchor="ctr"/>
           <a:lstStyle/>
           <a:p>
-            <a:pPr indent="0" marL="0">
+            <a:pPr marL="0" indent="0">
               <a:buNone/>
             </a:pPr>
             <a:r>
@@ -6463,6 +6537,13 @@
           </a:solidFill>
           <a:ln/>
         </p:spPr>
+        <p:txBody>
+          <a:bodyPr/>
+          <a:lstStyle/>
+          <a:p>
+            <a:endParaRPr lang="zh-CN" altLang="en-US"/>
+          </a:p>
+        </p:txBody>
       </p:sp>
       <p:sp>
         <p:nvSpPr>
@@ -6485,7 +6566,7 @@
           <a:bodyPr wrap="square" rtlCol="0" anchor="ctr"/>
           <a:lstStyle/>
           <a:p>
-            <a:pPr algn="ctr" indent="0" marL="0">
+            <a:pPr marL="0" indent="0" algn="ctr">
               <a:buNone/>
             </a:pPr>
             <a:r>
@@ -6519,6 +6600,7 @@
         <a:solidFill>
           <a:srgbClr val="FFFFFF"/>
         </a:solidFill>
+        <a:effectLst/>
       </p:bgPr>
     </p:bg>
     <p:spTree>
@@ -6554,6 +6636,13 @@
           </a:solidFill>
           <a:ln/>
         </p:spPr>
+        <p:txBody>
+          <a:bodyPr/>
+          <a:lstStyle/>
+          <a:p>
+            <a:endParaRPr lang="zh-CN" altLang="en-US"/>
+          </a:p>
+        </p:txBody>
       </p:sp>
       <p:sp>
         <p:nvSpPr>
@@ -6576,7 +6665,7 @@
           <a:bodyPr wrap="square" rtlCol="0" anchor="ctr"/>
           <a:lstStyle/>
           <a:p>
-            <a:pPr indent="0" marL="0">
+            <a:pPr marL="0" indent="0">
               <a:buNone/>
             </a:pPr>
             <a:r>
@@ -6613,13 +6702,20 @@
           </a:solidFill>
           <a:ln/>
           <a:effectLst>
-            <a:outerShdw sx="100000" sy="100000" kx="0" ky="0" algn="bl" rotWithShape="0" blurRad="76200" dist="25400" dir="16200000">
+            <a:outerShdw blurRad="76200" dist="25400" dir="16200000" algn="bl" rotWithShape="0">
               <a:srgbClr val="000000">
                 <a:alpha val="8000"/>
               </a:srgbClr>
             </a:outerShdw>
           </a:effectLst>
         </p:spPr>
+        <p:txBody>
+          <a:bodyPr/>
+          <a:lstStyle/>
+          <a:p>
+            <a:endParaRPr lang="zh-CN" altLang="en-US"/>
+          </a:p>
+        </p:txBody>
       </p:sp>
       <p:sp>
         <p:nvSpPr>
@@ -6640,6 +6736,13 @@
           </a:solidFill>
           <a:ln/>
         </p:spPr>
+        <p:txBody>
+          <a:bodyPr/>
+          <a:lstStyle/>
+          <a:p>
+            <a:endParaRPr lang="zh-CN" altLang="en-US"/>
+          </a:p>
+        </p:txBody>
       </p:sp>
       <p:sp>
         <p:nvSpPr>
@@ -6662,7 +6765,7 @@
           <a:bodyPr wrap="square" rtlCol="0" anchor="ctr"/>
           <a:lstStyle/>
           <a:p>
-            <a:pPr indent="0" marL="0">
+            <a:pPr marL="0" indent="0">
               <a:buNone/>
             </a:pPr>
             <a:r>
@@ -6701,7 +6804,7 @@
           <a:bodyPr wrap="square" rtlCol="0" anchor="ctr"/>
           <a:lstStyle/>
           <a:p>
-            <a:pPr indent="0" marL="0">
+            <a:pPr marL="0" indent="0">
               <a:lnSpc>
                 <a:spcPct val="150000"/>
               </a:lnSpc>
@@ -6721,7 +6824,7 @@
             <a:endParaRPr lang="en-US" sz="1100" dirty="0"/>
           </a:p>
           <a:p>
-            <a:pPr indent="0" marL="0">
+            <a:pPr marL="0" indent="0">
               <a:lnSpc>
                 <a:spcPct val="150000"/>
               </a:lnSpc>
@@ -6741,7 +6844,7 @@
             <a:endParaRPr lang="en-US" sz="1100" dirty="0"/>
           </a:p>
           <a:p>
-            <a:pPr indent="0" marL="0">
+            <a:pPr marL="0" indent="0">
               <a:lnSpc>
                 <a:spcPct val="150000"/>
               </a:lnSpc>
@@ -6761,7 +6864,7 @@
             <a:endParaRPr lang="en-US" sz="1100" dirty="0"/>
           </a:p>
           <a:p>
-            <a:pPr indent="0" marL="0">
+            <a:pPr marL="0" indent="0">
               <a:lnSpc>
                 <a:spcPct val="150000"/>
               </a:lnSpc>
@@ -6801,13 +6904,20 @@
           </a:solidFill>
           <a:ln/>
           <a:effectLst>
-            <a:outerShdw sx="100000" sy="100000" kx="0" ky="0" algn="bl" rotWithShape="0" blurRad="76200" dist="25400" dir="16200000">
+            <a:outerShdw blurRad="76200" dist="25400" dir="16200000" algn="bl" rotWithShape="0">
               <a:srgbClr val="000000">
                 <a:alpha val="8000"/>
               </a:srgbClr>
             </a:outerShdw>
           </a:effectLst>
         </p:spPr>
+        <p:txBody>
+          <a:bodyPr/>
+          <a:lstStyle/>
+          <a:p>
+            <a:endParaRPr lang="zh-CN" altLang="en-US"/>
+          </a:p>
+        </p:txBody>
       </p:sp>
       <p:sp>
         <p:nvSpPr>
@@ -6828,6 +6938,13 @@
           </a:solidFill>
           <a:ln/>
         </p:spPr>
+        <p:txBody>
+          <a:bodyPr/>
+          <a:lstStyle/>
+          <a:p>
+            <a:endParaRPr lang="zh-CN" altLang="en-US"/>
+          </a:p>
+        </p:txBody>
       </p:sp>
       <p:sp>
         <p:nvSpPr>
@@ -6850,7 +6967,7 @@
           <a:bodyPr wrap="square" rtlCol="0" anchor="ctr"/>
           <a:lstStyle/>
           <a:p>
-            <a:pPr indent="0" marL="0">
+            <a:pPr marL="0" indent="0">
               <a:buNone/>
             </a:pPr>
             <a:r>
@@ -6889,7 +7006,7 @@
           <a:bodyPr wrap="square" rtlCol="0" anchor="ctr"/>
           <a:lstStyle/>
           <a:p>
-            <a:pPr indent="0" marL="0">
+            <a:pPr marL="0" indent="0">
               <a:lnSpc>
                 <a:spcPct val="150000"/>
               </a:lnSpc>
@@ -6909,7 +7026,7 @@
             <a:endParaRPr lang="en-US" sz="1100" dirty="0"/>
           </a:p>
           <a:p>
-            <a:pPr indent="0" marL="0">
+            <a:pPr marL="0" indent="0">
               <a:lnSpc>
                 <a:spcPct val="150000"/>
               </a:lnSpc>
@@ -6929,7 +7046,7 @@
             <a:endParaRPr lang="en-US" sz="1100" dirty="0"/>
           </a:p>
           <a:p>
-            <a:pPr indent="0" marL="0">
+            <a:pPr marL="0" indent="0">
               <a:lnSpc>
                 <a:spcPct val="150000"/>
               </a:lnSpc>
@@ -6949,7 +7066,7 @@
             <a:endParaRPr lang="en-US" sz="1100" dirty="0"/>
           </a:p>
           <a:p>
-            <a:pPr indent="0" marL="0">
+            <a:pPr marL="0" indent="0">
               <a:lnSpc>
                 <a:spcPct val="150000"/>
               </a:lnSpc>
@@ -6989,13 +7106,20 @@
           </a:solidFill>
           <a:ln/>
           <a:effectLst>
-            <a:outerShdw sx="100000" sy="100000" kx="0" ky="0" algn="bl" rotWithShape="0" blurRad="76200" dist="25400" dir="16200000">
+            <a:outerShdw blurRad="76200" dist="25400" dir="16200000" algn="bl" rotWithShape="0">
               <a:srgbClr val="000000">
                 <a:alpha val="8000"/>
               </a:srgbClr>
             </a:outerShdw>
           </a:effectLst>
         </p:spPr>
+        <p:txBody>
+          <a:bodyPr/>
+          <a:lstStyle/>
+          <a:p>
+            <a:endParaRPr lang="zh-CN" altLang="en-US"/>
+          </a:p>
+        </p:txBody>
       </p:sp>
       <p:sp>
         <p:nvSpPr>
@@ -7016,6 +7140,13 @@
           </a:solidFill>
           <a:ln/>
         </p:spPr>
+        <p:txBody>
+          <a:bodyPr/>
+          <a:lstStyle/>
+          <a:p>
+            <a:endParaRPr lang="zh-CN" altLang="en-US"/>
+          </a:p>
+        </p:txBody>
       </p:sp>
       <p:sp>
         <p:nvSpPr>
@@ -7038,7 +7169,7 @@
           <a:bodyPr wrap="square" rtlCol="0" anchor="ctr"/>
           <a:lstStyle/>
           <a:p>
-            <a:pPr indent="0" marL="0">
+            <a:pPr marL="0" indent="0">
               <a:buNone/>
             </a:pPr>
             <a:r>
@@ -7077,7 +7208,7 @@
           <a:bodyPr wrap="square" rtlCol="0" anchor="ctr"/>
           <a:lstStyle/>
           <a:p>
-            <a:pPr indent="0" marL="0">
+            <a:pPr marL="0" indent="0">
               <a:lnSpc>
                 <a:spcPct val="150000"/>
               </a:lnSpc>
@@ -7097,7 +7228,7 @@
             <a:endParaRPr lang="en-US" sz="1100" dirty="0"/>
           </a:p>
           <a:p>
-            <a:pPr indent="0" marL="0">
+            <a:pPr marL="0" indent="0">
               <a:lnSpc>
                 <a:spcPct val="150000"/>
               </a:lnSpc>
@@ -7117,7 +7248,7 @@
             <a:endParaRPr lang="en-US" sz="1100" dirty="0"/>
           </a:p>
           <a:p>
-            <a:pPr indent="0" marL="0">
+            <a:pPr marL="0" indent="0">
               <a:lnSpc>
                 <a:spcPct val="150000"/>
               </a:lnSpc>
@@ -7137,7 +7268,7 @@
             <a:endParaRPr lang="en-US" sz="1100" dirty="0"/>
           </a:p>
           <a:p>
-            <a:pPr indent="0" marL="0">
+            <a:pPr marL="0" indent="0">
               <a:lnSpc>
                 <a:spcPct val="150000"/>
               </a:lnSpc>
@@ -7179,6 +7310,13 @@
           </a:solidFill>
           <a:ln/>
         </p:spPr>
+        <p:txBody>
+          <a:bodyPr/>
+          <a:lstStyle/>
+          <a:p>
+            <a:endParaRPr lang="zh-CN" altLang="en-US"/>
+          </a:p>
+        </p:txBody>
       </p:sp>
       <p:sp>
         <p:nvSpPr>
@@ -7201,7 +7339,7 @@
           <a:bodyPr wrap="square" rtlCol="0" anchor="ctr"/>
           <a:lstStyle/>
           <a:p>
-            <a:pPr indent="0" marL="0">
+            <a:pPr marL="0" indent="0">
               <a:buNone/>
             </a:pPr>
             <a:r>
@@ -7238,6 +7376,13 @@
           </a:solidFill>
           <a:ln/>
         </p:spPr>
+        <p:txBody>
+          <a:bodyPr/>
+          <a:lstStyle/>
+          <a:p>
+            <a:endParaRPr lang="zh-CN" altLang="en-US"/>
+          </a:p>
+        </p:txBody>
       </p:sp>
       <p:sp>
         <p:nvSpPr>
@@ -7260,7 +7405,7 @@
           <a:bodyPr wrap="square" rtlCol="0" anchor="ctr"/>
           <a:lstStyle/>
           <a:p>
-            <a:pPr algn="ctr" indent="0" marL="0">
+            <a:pPr marL="0" indent="0" algn="ctr">
               <a:buNone/>
             </a:pPr>
             <a:r>
@@ -7294,6 +7439,7 @@
         <a:solidFill>
           <a:srgbClr val="FFFFFF"/>
         </a:solidFill>
+        <a:effectLst/>
       </p:bgPr>
     </p:bg>
     <p:spTree>
@@ -7329,6 +7475,13 @@
           </a:solidFill>
           <a:ln/>
         </p:spPr>
+        <p:txBody>
+          <a:bodyPr/>
+          <a:lstStyle/>
+          <a:p>
+            <a:endParaRPr lang="zh-CN" altLang="en-US"/>
+          </a:p>
+        </p:txBody>
       </p:sp>
       <p:sp>
         <p:nvSpPr>
@@ -7351,7 +7504,7 @@
           <a:bodyPr wrap="square" rtlCol="0" anchor="ctr"/>
           <a:lstStyle/>
           <a:p>
-            <a:pPr indent="0" marL="0">
+            <a:pPr marL="0" indent="0">
               <a:buNone/>
             </a:pPr>
             <a:r>
@@ -7390,6 +7543,13 @@
           </a:solidFill>
           <a:ln/>
         </p:spPr>
+        <p:txBody>
+          <a:bodyPr/>
+          <a:lstStyle/>
+          <a:p>
+            <a:endParaRPr lang="zh-CN" altLang="en-US"/>
+          </a:p>
+        </p:txBody>
       </p:sp>
       <p:sp>
         <p:nvSpPr>
@@ -7412,7 +7572,7 @@
           <a:bodyPr wrap="square" rtlCol="0" anchor="ctr"/>
           <a:lstStyle/>
           <a:p>
-            <a:pPr algn="ctr" indent="0" marL="0">
+            <a:pPr marL="0" indent="0" algn="ctr">
               <a:buNone/>
             </a:pPr>
             <a:r>
@@ -7432,14 +7592,14 @@
       </p:sp>
       <p:pic>
         <p:nvPicPr>
-          <p:cNvPr id="6" name="Image 0" descr="F:\demo\slides\imgs\ui_01_upload.png">    </p:cNvPr>
+          <p:cNvPr id="6" name="Image 0" descr="F:\demo\slides\imgs\ui_01_upload.png"/>
           <p:cNvPicPr>
             <a:picLocks noChangeAspect="1"/>
           </p:cNvPicPr>
           <p:nvPr/>
         </p:nvPicPr>
         <p:blipFill>
-          <a:blip r:embed="rId1"/>
+          <a:blip r:embed="rId3"/>
           <a:stretch>
             <a:fillRect/>
           </a:stretch>
@@ -7475,6 +7635,13 @@
           </a:solidFill>
           <a:ln/>
         </p:spPr>
+        <p:txBody>
+          <a:bodyPr/>
+          <a:lstStyle/>
+          <a:p>
+            <a:endParaRPr lang="zh-CN" altLang="en-US"/>
+          </a:p>
+        </p:txBody>
       </p:sp>
       <p:sp>
         <p:nvSpPr>
@@ -7497,7 +7664,7 @@
           <a:bodyPr wrap="square" rtlCol="0" anchor="ctr"/>
           <a:lstStyle/>
           <a:p>
-            <a:pPr algn="ctr" indent="0" marL="0">
+            <a:pPr marL="0" indent="0" algn="ctr">
               <a:buNone/>
             </a:pPr>
             <a:r>
@@ -7517,14 +7684,14 @@
       </p:sp>
       <p:pic>
         <p:nvPicPr>
-          <p:cNvPr id="9" name="Image 1" descr="F:\demo\slides\imgs\ui_02_lesion.png">    </p:cNvPr>
+          <p:cNvPr id="9" name="Image 1" descr="F:\demo\slides\imgs\ui_02_lesion.png"/>
           <p:cNvPicPr>
             <a:picLocks noChangeAspect="1"/>
           </p:cNvPicPr>
           <p:nvPr/>
         </p:nvPicPr>
         <p:blipFill>
-          <a:blip r:embed="rId2"/>
+          <a:blip r:embed="rId4"/>
           <a:stretch>
             <a:fillRect/>
           </a:stretch>
@@ -7558,6 +7725,13 @@
           </a:solidFill>
           <a:ln/>
         </p:spPr>
+        <p:txBody>
+          <a:bodyPr/>
+          <a:lstStyle/>
+          <a:p>
+            <a:endParaRPr lang="zh-CN" altLang="en-US"/>
+          </a:p>
+        </p:txBody>
       </p:sp>
       <p:sp>
         <p:nvSpPr>
@@ -7580,7 +7754,7 @@
           <a:bodyPr wrap="square" rtlCol="0" anchor="ctr"/>
           <a:lstStyle/>
           <a:p>
-            <a:pPr algn="ctr" indent="0" marL="0">
+            <a:pPr marL="0" indent="0" algn="ctr">
               <a:buNone/>
             </a:pPr>
             <a:r>
@@ -7614,6 +7788,7 @@
         <a:solidFill>
           <a:srgbClr val="FFFFFF"/>
         </a:solidFill>
+        <a:effectLst/>
       </p:bgPr>
     </p:bg>
     <p:spTree>
@@ -7649,6 +7824,13 @@
           </a:solidFill>
           <a:ln/>
         </p:spPr>
+        <p:txBody>
+          <a:bodyPr/>
+          <a:lstStyle/>
+          <a:p>
+            <a:endParaRPr lang="zh-CN" altLang="en-US"/>
+          </a:p>
+        </p:txBody>
       </p:sp>
       <p:sp>
         <p:nvSpPr>
@@ -7671,7 +7853,7 @@
           <a:bodyPr wrap="square" rtlCol="0" anchor="ctr"/>
           <a:lstStyle/>
           <a:p>
-            <a:pPr indent="0" marL="0">
+            <a:pPr marL="0" indent="0">
               <a:buNone/>
             </a:pPr>
             <a:r>
@@ -7708,6 +7890,13 @@
           </a:solidFill>
           <a:ln/>
         </p:spPr>
+        <p:txBody>
+          <a:bodyPr/>
+          <a:lstStyle/>
+          <a:p>
+            <a:endParaRPr lang="zh-CN" altLang="en-US"/>
+          </a:p>
+        </p:txBody>
       </p:sp>
       <p:sp>
         <p:nvSpPr>
@@ -7730,7 +7919,7 @@
           <a:bodyPr wrap="square" rtlCol="0" anchor="ctr"/>
           <a:lstStyle/>
           <a:p>
-            <a:pPr algn="ctr" indent="0" marL="0">
+            <a:pPr marL="0" indent="0" algn="ctr">
               <a:buNone/>
             </a:pPr>
             <a:r>
@@ -7769,6 +7958,13 @@
           </a:solidFill>
           <a:ln/>
         </p:spPr>
+        <p:txBody>
+          <a:bodyPr/>
+          <a:lstStyle/>
+          <a:p>
+            <a:endParaRPr lang="zh-CN" altLang="en-US"/>
+          </a:p>
+        </p:txBody>
       </p:sp>
       <p:sp>
         <p:nvSpPr>
@@ -7791,7 +7987,7 @@
           <a:bodyPr wrap="square" rtlCol="0" anchor="ctr"/>
           <a:lstStyle/>
           <a:p>
-            <a:pPr algn="ctr" indent="0" marL="0">
+            <a:pPr marL="0" indent="0" algn="ctr">
               <a:buNone/>
             </a:pPr>
             <a:r>
@@ -7830,7 +8026,7 @@
           <a:bodyPr wrap="square" rtlCol="0" anchor="ctr"/>
           <a:lstStyle/>
           <a:p>
-            <a:pPr algn="ctr" indent="0" marL="0">
+            <a:pPr marL="0" indent="0" algn="ctr">
               <a:buNone/>
             </a:pPr>
             <a:r>
@@ -7869,7 +8065,7 @@
           <a:bodyPr wrap="square" rtlCol="0" anchor="ctr"/>
           <a:lstStyle/>
           <a:p>
-            <a:pPr algn="ctr" indent="0" marL="0">
+            <a:pPr marL="0" indent="0" algn="ctr">
               <a:buNone/>
             </a:pPr>
             <a:r>
@@ -7908,6 +8104,13 @@
           </a:solidFill>
           <a:ln/>
         </p:spPr>
+        <p:txBody>
+          <a:bodyPr/>
+          <a:lstStyle/>
+          <a:p>
+            <a:endParaRPr lang="zh-CN" altLang="en-US"/>
+          </a:p>
+        </p:txBody>
       </p:sp>
       <p:sp>
         <p:nvSpPr>
@@ -7930,7 +8133,7 @@
           <a:bodyPr wrap="square" rtlCol="0" anchor="ctr"/>
           <a:lstStyle/>
           <a:p>
-            <a:pPr algn="ctr" indent="0" marL="0">
+            <a:pPr marL="0" indent="0" algn="ctr">
               <a:buNone/>
             </a:pPr>
             <a:r>
@@ -7969,7 +8172,7 @@
           <a:bodyPr wrap="square" rtlCol="0" anchor="ctr"/>
           <a:lstStyle/>
           <a:p>
-            <a:pPr algn="ctr" indent="0" marL="0">
+            <a:pPr marL="0" indent="0" algn="ctr">
               <a:buNone/>
             </a:pPr>
             <a:r>
@@ -8008,7 +8211,7 @@
           <a:bodyPr wrap="square" rtlCol="0" anchor="ctr"/>
           <a:lstStyle/>
           <a:p>
-            <a:pPr algn="ctr" indent="0" marL="0">
+            <a:pPr marL="0" indent="0" algn="ctr">
               <a:buNone/>
             </a:pPr>
             <a:r>
@@ -8047,6 +8250,13 @@
           </a:solidFill>
           <a:ln/>
         </p:spPr>
+        <p:txBody>
+          <a:bodyPr/>
+          <a:lstStyle/>
+          <a:p>
+            <a:endParaRPr lang="zh-CN" altLang="en-US"/>
+          </a:p>
+        </p:txBody>
       </p:sp>
       <p:sp>
         <p:nvSpPr>
@@ -8069,7 +8279,7 @@
           <a:bodyPr wrap="square" rtlCol="0" anchor="ctr"/>
           <a:lstStyle/>
           <a:p>
-            <a:pPr algn="ctr" indent="0" marL="0">
+            <a:pPr marL="0" indent="0" algn="ctr">
               <a:buNone/>
             </a:pPr>
             <a:r>
@@ -8108,7 +8318,7 @@
           <a:bodyPr wrap="square" rtlCol="0" anchor="ctr"/>
           <a:lstStyle/>
           <a:p>
-            <a:pPr algn="ctr" indent="0" marL="0">
+            <a:pPr marL="0" indent="0" algn="ctr">
               <a:buNone/>
             </a:pPr>
             <a:r>
@@ -8147,7 +8357,7 @@
           <a:bodyPr wrap="square" rtlCol="0" anchor="ctr"/>
           <a:lstStyle/>
           <a:p>
-            <a:pPr algn="ctr" indent="0" marL="0">
+            <a:pPr marL="0" indent="0" algn="ctr">
               <a:buNone/>
             </a:pPr>
             <a:r>
@@ -8186,6 +8396,13 @@
           </a:solidFill>
           <a:ln/>
         </p:spPr>
+        <p:txBody>
+          <a:bodyPr/>
+          <a:lstStyle/>
+          <a:p>
+            <a:endParaRPr lang="zh-CN" altLang="en-US"/>
+          </a:p>
+        </p:txBody>
       </p:sp>
       <p:sp>
         <p:nvSpPr>
@@ -8208,7 +8425,7 @@
           <a:bodyPr wrap="square" rtlCol="0" anchor="ctr"/>
           <a:lstStyle/>
           <a:p>
-            <a:pPr algn="ctr" indent="0" marL="0">
+            <a:pPr marL="0" indent="0" algn="ctr">
               <a:buNone/>
             </a:pPr>
             <a:r>
@@ -8247,7 +8464,7 @@
           <a:bodyPr wrap="square" rtlCol="0" anchor="ctr"/>
           <a:lstStyle/>
           <a:p>
-            <a:pPr algn="ctr" indent="0" marL="0">
+            <a:pPr marL="0" indent="0" algn="ctr">
               <a:buNone/>
             </a:pPr>
             <a:r>
@@ -8286,7 +8503,7 @@
           <a:bodyPr wrap="square" rtlCol="0" anchor="ctr"/>
           <a:lstStyle/>
           <a:p>
-            <a:pPr algn="ctr" indent="0" marL="0">
+            <a:pPr marL="0" indent="0" algn="ctr">
               <a:buNone/>
             </a:pPr>
             <a:r>
@@ -8325,6 +8542,13 @@
           </a:solidFill>
           <a:ln/>
         </p:spPr>
+        <p:txBody>
+          <a:bodyPr/>
+          <a:lstStyle/>
+          <a:p>
+            <a:endParaRPr lang="zh-CN" altLang="en-US"/>
+          </a:p>
+        </p:txBody>
       </p:sp>
       <p:sp>
         <p:nvSpPr>
@@ -8347,7 +8571,7 @@
           <a:bodyPr wrap="square" rtlCol="0" anchor="ctr"/>
           <a:lstStyle/>
           <a:p>
-            <a:pPr algn="ctr" indent="0" marL="0">
+            <a:pPr marL="0" indent="0" algn="ctr">
               <a:buNone/>
             </a:pPr>
             <a:r>
@@ -8386,7 +8610,7 @@
           <a:bodyPr wrap="square" rtlCol="0" anchor="ctr"/>
           <a:lstStyle/>
           <a:p>
-            <a:pPr algn="ctr" indent="0" marL="0">
+            <a:pPr marL="0" indent="0" algn="ctr">
               <a:buNone/>
             </a:pPr>
             <a:r>
@@ -8425,7 +8649,7 @@
           <a:bodyPr wrap="square" rtlCol="0" anchor="ctr"/>
           <a:lstStyle/>
           <a:p>
-            <a:pPr algn="ctr" indent="0" marL="0">
+            <a:pPr marL="0" indent="0" algn="ctr">
               <a:buNone/>
             </a:pPr>
             <a:r>
@@ -8464,6 +8688,13 @@
           </a:solidFill>
           <a:ln/>
         </p:spPr>
+        <p:txBody>
+          <a:bodyPr/>
+          <a:lstStyle/>
+          <a:p>
+            <a:endParaRPr lang="zh-CN" altLang="en-US"/>
+          </a:p>
+        </p:txBody>
       </p:sp>
       <p:sp>
         <p:nvSpPr>
@@ -8486,7 +8717,7 @@
           <a:bodyPr wrap="square" rtlCol="0" anchor="ctr"/>
           <a:lstStyle/>
           <a:p>
-            <a:pPr algn="ctr" indent="0" marL="0">
+            <a:pPr marL="0" indent="0" algn="ctr">
               <a:buNone/>
             </a:pPr>
             <a:r>
@@ -8525,7 +8756,7 @@
           <a:bodyPr wrap="square" rtlCol="0" anchor="ctr"/>
           <a:lstStyle/>
           <a:p>
-            <a:pPr algn="ctr" indent="0" marL="0">
+            <a:pPr marL="0" indent="0" algn="ctr">
               <a:buNone/>
             </a:pPr>
             <a:r>
@@ -8564,7 +8795,7 @@
           <a:bodyPr wrap="square" rtlCol="0" anchor="ctr"/>
           <a:lstStyle/>
           <a:p>
-            <a:pPr algn="ctr" indent="0" marL="0">
+            <a:pPr marL="0" indent="0" algn="ctr">
               <a:buNone/>
             </a:pPr>
             <a:r>
@@ -8601,6 +8832,13 @@
           </a:solidFill>
           <a:ln/>
         </p:spPr>
+        <p:txBody>
+          <a:bodyPr/>
+          <a:lstStyle/>
+          <a:p>
+            <a:endParaRPr lang="zh-CN" altLang="en-US"/>
+          </a:p>
+        </p:txBody>
       </p:sp>
       <p:sp>
         <p:nvSpPr>
@@ -8623,7 +8861,7 @@
           <a:bodyPr wrap="square" rtlCol="0" anchor="ctr"/>
           <a:lstStyle/>
           <a:p>
-            <a:pPr algn="ctr" indent="0" marL="0">
+            <a:pPr marL="0" indent="0" algn="ctr">
               <a:buNone/>
             </a:pPr>
             <a:r>
@@ -8662,6 +8900,13 @@
           </a:solidFill>
           <a:ln/>
         </p:spPr>
+        <p:txBody>
+          <a:bodyPr/>
+          <a:lstStyle/>
+          <a:p>
+            <a:endParaRPr lang="zh-CN" altLang="en-US"/>
+          </a:p>
+        </p:txBody>
       </p:sp>
       <p:sp>
         <p:nvSpPr>
@@ -8684,7 +8929,7 @@
           <a:bodyPr wrap="square" rtlCol="0" anchor="ctr"/>
           <a:lstStyle/>
           <a:p>
-            <a:pPr indent="0" marL="0">
+            <a:pPr marL="0" indent="0">
               <a:buNone/>
             </a:pPr>
             <a:r>
@@ -8723,7 +8968,7 @@
           <a:bodyPr wrap="square" rtlCol="0" anchor="ctr"/>
           <a:lstStyle/>
           <a:p>
-            <a:pPr indent="0" marL="0">
+            <a:pPr marL="0" indent="0">
               <a:buNone/>
             </a:pPr>
             <a:r>
@@ -8740,7 +8985,7 @@
             <a:endParaRPr lang="en-US" sz="1000" dirty="0"/>
           </a:p>
           <a:p>
-            <a:pPr indent="0" marL="0">
+            <a:pPr marL="0" indent="0">
               <a:buNone/>
             </a:pPr>
             <a:r>
@@ -8779,7 +9024,7 @@
           <a:bodyPr wrap="square" rtlCol="0" anchor="ctr"/>
           <a:lstStyle/>
           <a:p>
-            <a:pPr indent="0" marL="0">
+            <a:pPr marL="0" indent="0">
               <a:buNone/>
             </a:pPr>
             <a:r>
@@ -8818,7 +9063,7 @@
           <a:bodyPr wrap="square" rtlCol="0" anchor="ctr"/>
           <a:lstStyle/>
           <a:p>
-            <a:pPr indent="0" marL="0">
+            <a:pPr marL="0" indent="0">
               <a:buNone/>
             </a:pPr>
             <a:r>
@@ -8835,7 +9080,7 @@
             <a:endParaRPr lang="en-US" sz="1000" dirty="0"/>
           </a:p>
           <a:p>
-            <a:pPr indent="0" marL="0">
+            <a:pPr marL="0" indent="0">
               <a:buNone/>
             </a:pPr>
             <a:r>
@@ -8874,7 +9119,7 @@
           <a:bodyPr wrap="square" rtlCol="0" anchor="ctr"/>
           <a:lstStyle/>
           <a:p>
-            <a:pPr indent="0" marL="0">
+            <a:pPr marL="0" indent="0">
               <a:buNone/>
             </a:pPr>
             <a:r>
@@ -8913,7 +9158,7 @@
           <a:bodyPr wrap="square" rtlCol="0" anchor="ctr"/>
           <a:lstStyle/>
           <a:p>
-            <a:pPr indent="0" marL="0">
+            <a:pPr marL="0" indent="0">
               <a:buNone/>
             </a:pPr>
             <a:r>
@@ -8930,7 +9175,7 @@
             <a:endParaRPr lang="en-US" sz="1000" dirty="0"/>
           </a:p>
           <a:p>
-            <a:pPr indent="0" marL="0">
+            <a:pPr marL="0" indent="0">
               <a:buNone/>
             </a:pPr>
             <a:r>
@@ -8969,7 +9214,7 @@
           <a:bodyPr wrap="square" rtlCol="0" anchor="ctr"/>
           <a:lstStyle/>
           <a:p>
-            <a:pPr indent="0" marL="0">
+            <a:pPr marL="0" indent="0">
               <a:buNone/>
             </a:pPr>
             <a:r>
@@ -9008,7 +9253,7 @@
           <a:bodyPr wrap="square" rtlCol="0" anchor="ctr"/>
           <a:lstStyle/>
           <a:p>
-            <a:pPr indent="0" marL="0">
+            <a:pPr marL="0" indent="0">
               <a:buNone/>
             </a:pPr>
             <a:r>
@@ -9025,7 +9270,7 @@
             <a:endParaRPr lang="en-US" sz="1000" dirty="0"/>
           </a:p>
           <a:p>
-            <a:pPr indent="0" marL="0">
+            <a:pPr marL="0" indent="0">
               <a:buNone/>
             </a:pPr>
             <a:r>
@@ -9062,6 +9307,13 @@
           </a:solidFill>
           <a:ln/>
         </p:spPr>
+        <p:txBody>
+          <a:bodyPr/>
+          <a:lstStyle/>
+          <a:p>
+            <a:endParaRPr lang="zh-CN" altLang="en-US"/>
+          </a:p>
+        </p:txBody>
       </p:sp>
       <p:sp>
         <p:nvSpPr>
@@ -9084,7 +9336,7 @@
           <a:bodyPr wrap="square" rtlCol="0" anchor="ctr"/>
           <a:lstStyle/>
           <a:p>
-            <a:pPr algn="ctr" indent="0" marL="0">
+            <a:pPr marL="0" indent="0" algn="ctr">
               <a:buNone/>
             </a:pPr>
             <a:r>
@@ -9118,6 +9370,7 @@
         <a:solidFill>
           <a:srgbClr val="FFFFFF"/>
         </a:solidFill>
+        <a:effectLst/>
       </p:bgPr>
     </p:bg>
     <p:spTree>
@@ -9153,6 +9406,13 @@
           </a:solidFill>
           <a:ln/>
         </p:spPr>
+        <p:txBody>
+          <a:bodyPr/>
+          <a:lstStyle/>
+          <a:p>
+            <a:endParaRPr lang="zh-CN" altLang="en-US"/>
+          </a:p>
+        </p:txBody>
       </p:sp>
       <p:sp>
         <p:nvSpPr>
@@ -9175,7 +9435,7 @@
           <a:bodyPr wrap="square" rtlCol="0" anchor="ctr"/>
           <a:lstStyle/>
           <a:p>
-            <a:pPr indent="0" marL="0">
+            <a:pPr marL="0" indent="0">
               <a:buNone/>
             </a:pPr>
             <a:r>
@@ -9214,6 +9474,13 @@
           </a:solidFill>
           <a:ln/>
         </p:spPr>
+        <p:txBody>
+          <a:bodyPr/>
+          <a:lstStyle/>
+          <a:p>
+            <a:endParaRPr lang="zh-CN" altLang="en-US"/>
+          </a:p>
+        </p:txBody>
       </p:sp>
       <p:sp>
         <p:nvSpPr>
@@ -9236,7 +9503,7 @@
           <a:bodyPr wrap="square" rtlCol="0" anchor="ctr"/>
           <a:lstStyle/>
           <a:p>
-            <a:pPr algn="ctr" indent="0" marL="0">
+            <a:pPr marL="0" indent="0" algn="ctr">
               <a:buNone/>
             </a:pPr>
             <a:r>
@@ -9256,14 +9523,14 @@
       </p:sp>
       <p:pic>
         <p:nvPicPr>
-          <p:cNvPr id="6" name="Image 0" descr="F:\demo\slides\imgs\ui_03_topo1.png">    </p:cNvPr>
+          <p:cNvPr id="6" name="Image 0" descr="F:\demo\slides\imgs\ui_03_topo1.png"/>
           <p:cNvPicPr>
             <a:picLocks noChangeAspect="1"/>
           </p:cNvPicPr>
           <p:nvPr/>
         </p:nvPicPr>
         <p:blipFill>
-          <a:blip r:embed="rId1"/>
+          <a:blip r:embed="rId3"/>
           <a:stretch>
             <a:fillRect/>
           </a:stretch>
@@ -9299,6 +9566,13 @@
           </a:solidFill>
           <a:ln/>
         </p:spPr>
+        <p:txBody>
+          <a:bodyPr/>
+          <a:lstStyle/>
+          <a:p>
+            <a:endParaRPr lang="zh-CN" altLang="en-US"/>
+          </a:p>
+        </p:txBody>
       </p:sp>
       <p:sp>
         <p:nvSpPr>
@@ -9321,7 +9595,7 @@
           <a:bodyPr wrap="square" rtlCol="0" anchor="ctr"/>
           <a:lstStyle/>
           <a:p>
-            <a:pPr algn="ctr" indent="0" marL="0">
+            <a:pPr marL="0" indent="0" algn="ctr">
               <a:buNone/>
             </a:pPr>
             <a:r>
@@ -9341,14 +9615,14 @@
       </p:sp>
       <p:pic>
         <p:nvPicPr>
-          <p:cNvPr id="9" name="Image 1" descr="F:\demo\slides\imgs\ui_04_topo2.png">    </p:cNvPr>
+          <p:cNvPr id="9" name="Image 1" descr="F:\demo\slides\imgs\ui_04_topo2.png"/>
           <p:cNvPicPr>
             <a:picLocks noChangeAspect="1"/>
           </p:cNvPicPr>
           <p:nvPr/>
         </p:nvPicPr>
         <p:blipFill>
-          <a:blip r:embed="rId2"/>
+          <a:blip r:embed="rId4"/>
           <a:stretch>
             <a:fillRect/>
           </a:stretch>
@@ -9382,6 +9656,13 @@
           </a:solidFill>
           <a:ln/>
         </p:spPr>
+        <p:txBody>
+          <a:bodyPr/>
+          <a:lstStyle/>
+          <a:p>
+            <a:endParaRPr lang="zh-CN" altLang="en-US"/>
+          </a:p>
+        </p:txBody>
       </p:sp>
       <p:sp>
         <p:nvSpPr>
@@ -9404,7 +9685,7 @@
           <a:bodyPr wrap="square" rtlCol="0" anchor="ctr"/>
           <a:lstStyle/>
           <a:p>
-            <a:pPr algn="ctr" indent="0" marL="0">
+            <a:pPr marL="0" indent="0" algn="ctr">
               <a:buNone/>
             </a:pPr>
             <a:r>
@@ -9438,6 +9719,7 @@
         <a:solidFill>
           <a:srgbClr val="FFFFFF"/>
         </a:solidFill>
+        <a:effectLst/>
       </p:bgPr>
     </p:bg>
     <p:spTree>
@@ -9473,6 +9755,13 @@
           </a:solidFill>
           <a:ln/>
         </p:spPr>
+        <p:txBody>
+          <a:bodyPr/>
+          <a:lstStyle/>
+          <a:p>
+            <a:endParaRPr lang="zh-CN" altLang="en-US"/>
+          </a:p>
+        </p:txBody>
       </p:sp>
       <p:sp>
         <p:nvSpPr>
@@ -9495,7 +9784,7 @@
           <a:bodyPr wrap="square" rtlCol="0" anchor="ctr"/>
           <a:lstStyle/>
           <a:p>
-            <a:pPr indent="0" marL="0">
+            <a:pPr marL="0" indent="0">
               <a:buNone/>
             </a:pPr>
             <a:r>
@@ -9532,13 +9821,20 @@
           </a:solidFill>
           <a:ln/>
           <a:effectLst>
-            <a:outerShdw sx="100000" sy="100000" kx="0" ky="0" algn="bl" rotWithShape="0" blurRad="50800" dist="25400" dir="16200000">
+            <a:outerShdw blurRad="50800" dist="25400" dir="16200000" algn="bl" rotWithShape="0">
               <a:srgbClr val="000000">
                 <a:alpha val="6000"/>
               </a:srgbClr>
             </a:outerShdw>
           </a:effectLst>
         </p:spPr>
+        <p:txBody>
+          <a:bodyPr/>
+          <a:lstStyle/>
+          <a:p>
+            <a:endParaRPr lang="zh-CN" altLang="en-US"/>
+          </a:p>
+        </p:txBody>
       </p:sp>
       <p:sp>
         <p:nvSpPr>
@@ -9559,6 +9855,13 @@
           </a:solidFill>
           <a:ln/>
         </p:spPr>
+        <p:txBody>
+          <a:bodyPr/>
+          <a:lstStyle/>
+          <a:p>
+            <a:endParaRPr lang="zh-CN" altLang="en-US"/>
+          </a:p>
+        </p:txBody>
       </p:sp>
       <p:sp>
         <p:nvSpPr>
@@ -9581,7 +9884,7 @@
           <a:bodyPr wrap="square" rtlCol="0" anchor="ctr"/>
           <a:lstStyle/>
           <a:p>
-            <a:pPr algn="ctr" indent="0" marL="0">
+            <a:pPr marL="0" indent="0" algn="ctr">
               <a:buNone/>
             </a:pPr>
             <a:r>
@@ -9620,7 +9923,7 @@
           <a:bodyPr wrap="square" rtlCol="0" anchor="ctr"/>
           <a:lstStyle/>
           <a:p>
-            <a:pPr algn="ctr" indent="0" marL="0">
+            <a:pPr marL="0" indent="0" algn="ctr">
               <a:buNone/>
             </a:pPr>
             <a:r>
@@ -9659,7 +9962,7 @@
           <a:bodyPr wrap="square" rtlCol="0" anchor="ctr"/>
           <a:lstStyle/>
           <a:p>
-            <a:pPr indent="0" marL="0">
+            <a:pPr marL="0" indent="0">
               <a:buNone/>
             </a:pPr>
             <a:r>
@@ -9698,7 +10001,7 @@
           <a:bodyPr wrap="square" rtlCol="0" anchor="ctr"/>
           <a:lstStyle/>
           <a:p>
-            <a:pPr indent="0" marL="0">
+            <a:pPr marL="0" indent="0">
               <a:buNone/>
             </a:pPr>
             <a:r>
@@ -9737,7 +10040,7 @@
           <a:bodyPr wrap="square" rtlCol="0" anchor="ctr"/>
           <a:lstStyle/>
           <a:p>
-            <a:pPr indent="0" marL="0">
+            <a:pPr marL="0" indent="0">
               <a:buNone/>
             </a:pPr>
             <a:r>
@@ -9776,7 +10079,7 @@
           <a:bodyPr wrap="square" rtlCol="0" anchor="ctr"/>
           <a:lstStyle/>
           <a:p>
-            <a:pPr indent="0" marL="0">
+            <a:pPr marL="0" indent="0">
               <a:buNone/>
             </a:pPr>
             <a:r>
@@ -9813,13 +10116,20 @@
           </a:solidFill>
           <a:ln/>
           <a:effectLst>
-            <a:outerShdw sx="100000" sy="100000" kx="0" ky="0" algn="bl" rotWithShape="0" blurRad="50800" dist="25400" dir="16200000">
+            <a:outerShdw blurRad="50800" dist="25400" dir="16200000" algn="bl" rotWithShape="0">
               <a:srgbClr val="000000">
                 <a:alpha val="6000"/>
               </a:srgbClr>
             </a:outerShdw>
           </a:effectLst>
         </p:spPr>
+        <p:txBody>
+          <a:bodyPr/>
+          <a:lstStyle/>
+          <a:p>
+            <a:endParaRPr lang="zh-CN" altLang="en-US"/>
+          </a:p>
+        </p:txBody>
       </p:sp>
       <p:sp>
         <p:nvSpPr>
@@ -9840,6 +10150,13 @@
           </a:solidFill>
           <a:ln/>
         </p:spPr>
+        <p:txBody>
+          <a:bodyPr/>
+          <a:lstStyle/>
+          <a:p>
+            <a:endParaRPr lang="zh-CN" altLang="en-US"/>
+          </a:p>
+        </p:txBody>
       </p:sp>
       <p:sp>
         <p:nvSpPr>
@@ -9862,7 +10179,7 @@
           <a:bodyPr wrap="square" rtlCol="0" anchor="ctr"/>
           <a:lstStyle/>
           <a:p>
-            <a:pPr algn="ctr" indent="0" marL="0">
+            <a:pPr marL="0" indent="0" algn="ctr">
               <a:buNone/>
             </a:pPr>
             <a:r>
@@ -9901,7 +10218,7 @@
           <a:bodyPr wrap="square" rtlCol="0" anchor="ctr"/>
           <a:lstStyle/>
           <a:p>
-            <a:pPr algn="ctr" indent="0" marL="0">
+            <a:pPr marL="0" indent="0" algn="ctr">
               <a:buNone/>
             </a:pPr>
             <a:r>
@@ -9940,7 +10257,7 @@
           <a:bodyPr wrap="square" rtlCol="0" anchor="ctr"/>
           <a:lstStyle/>
           <a:p>
-            <a:pPr indent="0" marL="0">
+            <a:pPr marL="0" indent="0">
               <a:buNone/>
             </a:pPr>
             <a:r>
@@ -9979,7 +10296,7 @@
           <a:bodyPr wrap="square" rtlCol="0" anchor="ctr"/>
           <a:lstStyle/>
           <a:p>
-            <a:pPr indent="0" marL="0">
+            <a:pPr marL="0" indent="0">
               <a:buNone/>
             </a:pPr>
             <a:r>
@@ -10018,7 +10335,7 @@
           <a:bodyPr wrap="square" rtlCol="0" anchor="ctr"/>
           <a:lstStyle/>
           <a:p>
-            <a:pPr indent="0" marL="0">
+            <a:pPr marL="0" indent="0">
               <a:buNone/>
             </a:pPr>
             <a:r>
@@ -10057,7 +10374,7 @@
           <a:bodyPr wrap="square" rtlCol="0" anchor="ctr"/>
           <a:lstStyle/>
           <a:p>
-            <a:pPr indent="0" marL="0">
+            <a:pPr marL="0" indent="0">
               <a:buNone/>
             </a:pPr>
             <a:r>
@@ -10094,13 +10411,20 @@
           </a:solidFill>
           <a:ln/>
           <a:effectLst>
-            <a:outerShdw sx="100000" sy="100000" kx="0" ky="0" algn="bl" rotWithShape="0" blurRad="50800" dist="25400" dir="16200000">
+            <a:outerShdw blurRad="50800" dist="25400" dir="16200000" algn="bl" rotWithShape="0">
               <a:srgbClr val="000000">
                 <a:alpha val="6000"/>
               </a:srgbClr>
             </a:outerShdw>
           </a:effectLst>
         </p:spPr>
+        <p:txBody>
+          <a:bodyPr/>
+          <a:lstStyle/>
+          <a:p>
+            <a:endParaRPr lang="zh-CN" altLang="en-US"/>
+          </a:p>
+        </p:txBody>
       </p:sp>
       <p:sp>
         <p:nvSpPr>
@@ -10121,6 +10445,13 @@
           </a:solidFill>
           <a:ln/>
         </p:spPr>
+        <p:txBody>
+          <a:bodyPr/>
+          <a:lstStyle/>
+          <a:p>
+            <a:endParaRPr lang="zh-CN" altLang="en-US"/>
+          </a:p>
+        </p:txBody>
       </p:sp>
       <p:sp>
         <p:nvSpPr>
@@ -10143,7 +10474,7 @@
           <a:bodyPr wrap="square" rtlCol="0" anchor="ctr"/>
           <a:lstStyle/>
           <a:p>
-            <a:pPr algn="ctr" indent="0" marL="0">
+            <a:pPr marL="0" indent="0" algn="ctr">
               <a:buNone/>
             </a:pPr>
             <a:r>
@@ -10182,7 +10513,7 @@
           <a:bodyPr wrap="square" rtlCol="0" anchor="ctr"/>
           <a:lstStyle/>
           <a:p>
-            <a:pPr algn="ctr" indent="0" marL="0">
+            <a:pPr marL="0" indent="0" algn="ctr">
               <a:buNone/>
             </a:pPr>
             <a:r>
@@ -10221,7 +10552,7 @@
           <a:bodyPr wrap="square" rtlCol="0" anchor="ctr"/>
           <a:lstStyle/>
           <a:p>
-            <a:pPr indent="0" marL="0">
+            <a:pPr marL="0" indent="0">
               <a:buNone/>
             </a:pPr>
             <a:r>
@@ -10260,7 +10591,7 @@
           <a:bodyPr wrap="square" rtlCol="0" anchor="ctr"/>
           <a:lstStyle/>
           <a:p>
-            <a:pPr indent="0" marL="0">
+            <a:pPr marL="0" indent="0">
               <a:buNone/>
             </a:pPr>
             <a:r>
@@ -10299,7 +10630,7 @@
           <a:bodyPr wrap="square" rtlCol="0" anchor="ctr"/>
           <a:lstStyle/>
           <a:p>
-            <a:pPr indent="0" marL="0">
+            <a:pPr marL="0" indent="0">
               <a:buNone/>
             </a:pPr>
             <a:r>
@@ -10338,7 +10669,7 @@
           <a:bodyPr wrap="square" rtlCol="0" anchor="ctr"/>
           <a:lstStyle/>
           <a:p>
-            <a:pPr indent="0" marL="0">
+            <a:pPr marL="0" indent="0">
               <a:buNone/>
             </a:pPr>
             <a:r>
@@ -10375,6 +10706,13 @@
           </a:solidFill>
           <a:ln/>
         </p:spPr>
+        <p:txBody>
+          <a:bodyPr/>
+          <a:lstStyle/>
+          <a:p>
+            <a:endParaRPr lang="zh-CN" altLang="en-US"/>
+          </a:p>
+        </p:txBody>
       </p:sp>
       <p:sp>
         <p:nvSpPr>
@@ -10397,7 +10735,7 @@
           <a:bodyPr wrap="square" rtlCol="0" anchor="ctr"/>
           <a:lstStyle/>
           <a:p>
-            <a:pPr algn="ctr" indent="0" marL="0">
+            <a:pPr marL="0" indent="0" algn="ctr">
               <a:buNone/>
             </a:pPr>
             <a:r>
@@ -10431,6 +10769,7 @@
         <a:solidFill>
           <a:srgbClr val="FFFFFF"/>
         </a:solidFill>
+        <a:effectLst/>
       </p:bgPr>
     </p:bg>
     <p:spTree>
@@ -10466,6 +10805,13 @@
           </a:solidFill>
           <a:ln/>
         </p:spPr>
+        <p:txBody>
+          <a:bodyPr/>
+          <a:lstStyle/>
+          <a:p>
+            <a:endParaRPr lang="zh-CN" altLang="en-US"/>
+          </a:p>
+        </p:txBody>
       </p:sp>
       <p:sp>
         <p:nvSpPr>
@@ -10488,7 +10834,7 @@
           <a:bodyPr wrap="square" rtlCol="0" anchor="ctr"/>
           <a:lstStyle/>
           <a:p>
-            <a:pPr indent="0" marL="0">
+            <a:pPr marL="0" indent="0">
               <a:buNone/>
             </a:pPr>
             <a:r>
@@ -10527,6 +10873,13 @@
           </a:solidFill>
           <a:ln/>
         </p:spPr>
+        <p:txBody>
+          <a:bodyPr/>
+          <a:lstStyle/>
+          <a:p>
+            <a:endParaRPr lang="zh-CN" altLang="en-US"/>
+          </a:p>
+        </p:txBody>
       </p:sp>
       <p:sp>
         <p:nvSpPr>
@@ -10549,7 +10902,7 @@
           <a:bodyPr wrap="square" rtlCol="0" anchor="ctr"/>
           <a:lstStyle/>
           <a:p>
-            <a:pPr algn="ctr" indent="0" marL="0">
+            <a:pPr marL="0" indent="0" algn="ctr">
               <a:buNone/>
             </a:pPr>
             <a:r>
@@ -10569,14 +10922,14 @@
       </p:sp>
       <p:pic>
         <p:nvPicPr>
-          <p:cNvPr id="6" name="Image 0" descr="F:\demo\slides\imgs\ui_07_topic.png">    </p:cNvPr>
+          <p:cNvPr id="6" name="Image 0" descr="F:\demo\slides\imgs\ui_07_topic.png"/>
           <p:cNvPicPr>
             <a:picLocks noChangeAspect="1"/>
           </p:cNvPicPr>
           <p:nvPr/>
         </p:nvPicPr>
         <p:blipFill>
-          <a:blip r:embed="rId1"/>
+          <a:blip r:embed="rId3"/>
           <a:stretch>
             <a:fillRect/>
           </a:stretch>
@@ -10612,6 +10965,13 @@
           </a:solidFill>
           <a:ln/>
         </p:spPr>
+        <p:txBody>
+          <a:bodyPr/>
+          <a:lstStyle/>
+          <a:p>
+            <a:endParaRPr lang="zh-CN" altLang="en-US"/>
+          </a:p>
+        </p:txBody>
       </p:sp>
       <p:sp>
         <p:nvSpPr>
@@ -10634,7 +10994,7 @@
           <a:bodyPr wrap="square" rtlCol="0" anchor="ctr"/>
           <a:lstStyle/>
           <a:p>
-            <a:pPr algn="ctr" indent="0" marL="0">
+            <a:pPr marL="0" indent="0" algn="ctr">
               <a:buNone/>
             </a:pPr>
             <a:r>
@@ -10654,14 +11014,14 @@
       </p:sp>
       <p:pic>
         <p:nvPicPr>
-          <p:cNvPr id="9" name="Image 1" descr="F:\demo\slides\imgs\ui_05_api.png">    </p:cNvPr>
+          <p:cNvPr id="9" name="Image 1" descr="F:\demo\slides\imgs\ui_05_api.png"/>
           <p:cNvPicPr>
             <a:picLocks noChangeAspect="1"/>
           </p:cNvPicPr>
           <p:nvPr/>
         </p:nvPicPr>
         <p:blipFill>
-          <a:blip r:embed="rId2"/>
+          <a:blip r:embed="rId4"/>
           <a:stretch>
             <a:fillRect/>
           </a:stretch>
@@ -10695,6 +11055,13 @@
           </a:solidFill>
           <a:ln/>
         </p:spPr>
+        <p:txBody>
+          <a:bodyPr/>
+          <a:lstStyle/>
+          <a:p>
+            <a:endParaRPr lang="zh-CN" altLang="en-US"/>
+          </a:p>
+        </p:txBody>
       </p:sp>
       <p:sp>
         <p:nvSpPr>
@@ -10717,7 +11084,7 @@
           <a:bodyPr wrap="square" rtlCol="0" anchor="ctr"/>
           <a:lstStyle/>
           <a:p>
-            <a:pPr algn="ctr" indent="0" marL="0">
+            <a:pPr marL="0" indent="0" algn="ctr">
               <a:buNone/>
             </a:pPr>
             <a:r>
@@ -11036,4 +11403,319 @@
     </a:ext>
   </a:extLst>
 </a:theme>
+</file>
+
+<file path=ppt/theme/theme2.xml><?xml version="1.0" encoding="utf-8"?>
+<a:theme xmlns:a="http://schemas.openxmlformats.org/drawingml/2006/main" name="Office 主题​​">
+  <a:themeElements>
+    <a:clrScheme name="Office">
+      <a:dk1>
+        <a:sysClr val="windowText" lastClr="000000"/>
+      </a:dk1>
+      <a:lt1>
+        <a:sysClr val="window" lastClr="FFFFFF"/>
+      </a:lt1>
+      <a:dk2>
+        <a:srgbClr val="0E2841"/>
+      </a:dk2>
+      <a:lt2>
+        <a:srgbClr val="E8E8E8"/>
+      </a:lt2>
+      <a:accent1>
+        <a:srgbClr val="156082"/>
+      </a:accent1>
+      <a:accent2>
+        <a:srgbClr val="E97132"/>
+      </a:accent2>
+      <a:accent3>
+        <a:srgbClr val="196B24"/>
+      </a:accent3>
+      <a:accent4>
+        <a:srgbClr val="0F9ED5"/>
+      </a:accent4>
+      <a:accent5>
+        <a:srgbClr val="A02B93"/>
+      </a:accent5>
+      <a:accent6>
+        <a:srgbClr val="4EA72E"/>
+      </a:accent6>
+      <a:hlink>
+        <a:srgbClr val="467886"/>
+      </a:hlink>
+      <a:folHlink>
+        <a:srgbClr val="96607D"/>
+      </a:folHlink>
+    </a:clrScheme>
+    <a:fontScheme name="Office">
+      <a:majorFont>
+        <a:latin typeface="等线 Light" panose="02110004020202020204"/>
+        <a:ea typeface=""/>
+        <a:cs typeface=""/>
+        <a:font script="Jpan" typeface="游ゴシック Light"/>
+        <a:font script="Hang" typeface="맑은 고딕"/>
+        <a:font script="Hans" typeface="等线 Light"/>
+        <a:font script="Hant" typeface="新細明體"/>
+        <a:font script="Arab" typeface="Times New Roman"/>
+        <a:font script="Hebr" typeface="Times New Roman"/>
+        <a:font script="Thai" typeface="Angsana New"/>
+        <a:font script="Ethi" typeface="Nyala"/>
+        <a:font script="Beng" typeface="Vrinda"/>
+        <a:font script="Gujr" typeface="Shruti"/>
+        <a:font script="Khmr" typeface="MoolBoran"/>
+        <a:font script="Knda" typeface="Tunga"/>
+        <a:font script="Guru" typeface="Raavi"/>
+        <a:font script="Cans" typeface="Euphemia"/>
+        <a:font script="Cher" typeface="Plantagenet Cherokee"/>
+        <a:font script="Yiii" typeface="Microsoft Yi Baiti"/>
+        <a:font script="Tibt" typeface="Microsoft Himalaya"/>
+        <a:font script="Thaa" typeface="MV Boli"/>
+        <a:font script="Deva" typeface="Mangal"/>
+        <a:font script="Telu" typeface="Gautami"/>
+        <a:font script="Taml" typeface="Latha"/>
+        <a:font script="Syrc" typeface="Estrangelo Edessa"/>
+        <a:font script="Orya" typeface="Kalinga"/>
+        <a:font script="Mlym" typeface="Kartika"/>
+        <a:font script="Laoo" typeface="DokChampa"/>
+        <a:font script="Sinh" typeface="Iskoola Pota"/>
+        <a:font script="Mong" typeface="Mongolian Baiti"/>
+        <a:font script="Viet" typeface="Times New Roman"/>
+        <a:font script="Uigh" typeface="Microsoft Uighur"/>
+        <a:font script="Geor" typeface="Sylfaen"/>
+        <a:font script="Armn" typeface="Arial"/>
+        <a:font script="Bugi" typeface="Leelawadee UI"/>
+        <a:font script="Bopo" typeface="Microsoft JhengHei"/>
+        <a:font script="Java" typeface="Javanese Text"/>
+        <a:font script="Lisu" typeface="Segoe UI"/>
+        <a:font script="Mymr" typeface="Myanmar Text"/>
+        <a:font script="Nkoo" typeface="Ebrima"/>
+        <a:font script="Olck" typeface="Nirmala UI"/>
+        <a:font script="Osma" typeface="Ebrima"/>
+        <a:font script="Phag" typeface="Phagspa"/>
+        <a:font script="Syrn" typeface="Estrangelo Edessa"/>
+        <a:font script="Syrj" typeface="Estrangelo Edessa"/>
+        <a:font script="Syre" typeface="Estrangelo Edessa"/>
+        <a:font script="Sora" typeface="Nirmala UI"/>
+        <a:font script="Tale" typeface="Microsoft Tai Le"/>
+        <a:font script="Talu" typeface="Microsoft New Tai Lue"/>
+        <a:font script="Tfng" typeface="Ebrima"/>
+      </a:majorFont>
+      <a:minorFont>
+        <a:latin typeface="等线" panose="02110004020202020204"/>
+        <a:ea typeface=""/>
+        <a:cs typeface=""/>
+        <a:font script="Jpan" typeface="游ゴシック"/>
+        <a:font script="Hang" typeface="맑은 고딕"/>
+        <a:font script="Hans" typeface="等线"/>
+        <a:font script="Hant" typeface="新細明體"/>
+        <a:font script="Arab" typeface="Arial"/>
+        <a:font script="Hebr" typeface="Arial"/>
+        <a:font script="Thai" typeface="Cordia New"/>
+        <a:font script="Ethi" typeface="Nyala"/>
+        <a:font script="Beng" typeface="Vrinda"/>
+        <a:font script="Gujr" typeface="Shruti"/>
+        <a:font script="Khmr" typeface="DaunPenh"/>
+        <a:font script="Knda" typeface="Tunga"/>
+        <a:font script="Guru" typeface="Raavi"/>
+        <a:font script="Cans" typeface="Euphemia"/>
+        <a:font script="Cher" typeface="Plantagenet Cherokee"/>
+        <a:font script="Yiii" typeface="Microsoft Yi Baiti"/>
+        <a:font script="Tibt" typeface="Microsoft Himalaya"/>
+        <a:font script="Thaa" typeface="MV Boli"/>
+        <a:font script="Deva" typeface="Mangal"/>
+        <a:font script="Telu" typeface="Gautami"/>
+        <a:font script="Taml" typeface="Latha"/>
+        <a:font script="Syrc" typeface="Estrangelo Edessa"/>
+        <a:font script="Orya" typeface="Kalinga"/>
+        <a:font script="Mlym" typeface="Kartika"/>
+        <a:font script="Laoo" typeface="DokChampa"/>
+        <a:font script="Sinh" typeface="Iskoola Pota"/>
+        <a:font script="Mong" typeface="Mongolian Baiti"/>
+        <a:font script="Viet" typeface="Arial"/>
+        <a:font script="Uigh" typeface="Microsoft Uighur"/>
+        <a:font script="Geor" typeface="Sylfaen"/>
+        <a:font script="Armn" typeface="Arial"/>
+        <a:font script="Bugi" typeface="Leelawadee UI"/>
+        <a:font script="Bopo" typeface="Microsoft JhengHei"/>
+        <a:font script="Java" typeface="Javanese Text"/>
+        <a:font script="Lisu" typeface="Segoe UI"/>
+        <a:font script="Mymr" typeface="Myanmar Text"/>
+        <a:font script="Nkoo" typeface="Ebrima"/>
+        <a:font script="Olck" typeface="Nirmala UI"/>
+        <a:font script="Osma" typeface="Ebrima"/>
+        <a:font script="Phag" typeface="Phagspa"/>
+        <a:font script="Syrn" typeface="Estrangelo Edessa"/>
+        <a:font script="Syrj" typeface="Estrangelo Edessa"/>
+        <a:font script="Syre" typeface="Estrangelo Edessa"/>
+        <a:font script="Sora" typeface="Nirmala UI"/>
+        <a:font script="Tale" typeface="Microsoft Tai Le"/>
+        <a:font script="Talu" typeface="Microsoft New Tai Lue"/>
+        <a:font script="Tfng" typeface="Ebrima"/>
+      </a:minorFont>
+    </a:fontScheme>
+    <a:fmtScheme name="Office">
+      <a:fillStyleLst>
+        <a:solidFill>
+          <a:schemeClr val="phClr"/>
+        </a:solidFill>
+        <a:gradFill rotWithShape="1">
+          <a:gsLst>
+            <a:gs pos="0">
+              <a:schemeClr val="phClr">
+                <a:lumMod val="110000"/>
+                <a:satMod val="105000"/>
+                <a:tint val="67000"/>
+              </a:schemeClr>
+            </a:gs>
+            <a:gs pos="50000">
+              <a:schemeClr val="phClr">
+                <a:lumMod val="105000"/>
+                <a:satMod val="103000"/>
+                <a:tint val="73000"/>
+              </a:schemeClr>
+            </a:gs>
+            <a:gs pos="100000">
+              <a:schemeClr val="phClr">
+                <a:lumMod val="105000"/>
+                <a:satMod val="109000"/>
+                <a:tint val="81000"/>
+              </a:schemeClr>
+            </a:gs>
+          </a:gsLst>
+          <a:lin ang="5400000" scaled="0"/>
+        </a:gradFill>
+        <a:gradFill rotWithShape="1">
+          <a:gsLst>
+            <a:gs pos="0">
+              <a:schemeClr val="phClr">
+                <a:satMod val="103000"/>
+                <a:lumMod val="102000"/>
+                <a:tint val="94000"/>
+              </a:schemeClr>
+            </a:gs>
+            <a:gs pos="50000">
+              <a:schemeClr val="phClr">
+                <a:satMod val="110000"/>
+                <a:lumMod val="100000"/>
+                <a:shade val="100000"/>
+              </a:schemeClr>
+            </a:gs>
+            <a:gs pos="100000">
+              <a:schemeClr val="phClr">
+                <a:lumMod val="99000"/>
+                <a:satMod val="120000"/>
+                <a:shade val="78000"/>
+              </a:schemeClr>
+            </a:gs>
+          </a:gsLst>
+          <a:lin ang="5400000" scaled="0"/>
+        </a:gradFill>
+      </a:fillStyleLst>
+      <a:lnStyleLst>
+        <a:ln w="12700" cap="flat" cmpd="sng" algn="ctr">
+          <a:solidFill>
+            <a:schemeClr val="phClr"/>
+          </a:solidFill>
+          <a:prstDash val="solid"/>
+          <a:miter lim="800000"/>
+        </a:ln>
+        <a:ln w="19050" cap="flat" cmpd="sng" algn="ctr">
+          <a:solidFill>
+            <a:schemeClr val="phClr"/>
+          </a:solidFill>
+          <a:prstDash val="solid"/>
+          <a:miter lim="800000"/>
+        </a:ln>
+        <a:ln w="25400" cap="flat" cmpd="sng" algn="ctr">
+          <a:solidFill>
+            <a:schemeClr val="phClr"/>
+          </a:solidFill>
+          <a:prstDash val="solid"/>
+          <a:miter lim="800000"/>
+        </a:ln>
+      </a:lnStyleLst>
+      <a:effectStyleLst>
+        <a:effectStyle>
+          <a:effectLst/>
+        </a:effectStyle>
+        <a:effectStyle>
+          <a:effectLst/>
+        </a:effectStyle>
+        <a:effectStyle>
+          <a:effectLst>
+            <a:outerShdw blurRad="57150" dist="19050" dir="5400000" algn="ctr" rotWithShape="0">
+              <a:srgbClr val="000000">
+                <a:alpha val="63000"/>
+              </a:srgbClr>
+            </a:outerShdw>
+          </a:effectLst>
+        </a:effectStyle>
+      </a:effectStyleLst>
+      <a:bgFillStyleLst>
+        <a:solidFill>
+          <a:schemeClr val="phClr"/>
+        </a:solidFill>
+        <a:solidFill>
+          <a:schemeClr val="phClr">
+            <a:tint val="95000"/>
+            <a:satMod val="170000"/>
+          </a:schemeClr>
+        </a:solidFill>
+        <a:gradFill rotWithShape="1">
+          <a:gsLst>
+            <a:gs pos="0">
+              <a:schemeClr val="phClr">
+                <a:tint val="93000"/>
+                <a:satMod val="150000"/>
+                <a:shade val="98000"/>
+                <a:lumMod val="102000"/>
+              </a:schemeClr>
+            </a:gs>
+            <a:gs pos="50000">
+              <a:schemeClr val="phClr">
+                <a:tint val="98000"/>
+                <a:satMod val="130000"/>
+                <a:shade val="90000"/>
+                <a:lumMod val="103000"/>
+              </a:schemeClr>
+            </a:gs>
+            <a:gs pos="100000">
+              <a:schemeClr val="phClr">
+                <a:shade val="63000"/>
+                <a:satMod val="120000"/>
+              </a:schemeClr>
+            </a:gs>
+          </a:gsLst>
+          <a:lin ang="5400000" scaled="0"/>
+        </a:gradFill>
+      </a:bgFillStyleLst>
+    </a:fmtScheme>
+  </a:themeElements>
+  <a:objectDefaults>
+    <a:lnDef>
+      <a:spPr/>
+      <a:bodyPr/>
+      <a:lstStyle/>
+      <a:style>
+        <a:lnRef idx="2">
+          <a:schemeClr val="accent1"/>
+        </a:lnRef>
+        <a:fillRef idx="0">
+          <a:schemeClr val="accent1"/>
+        </a:fillRef>
+        <a:effectRef idx="1">
+          <a:schemeClr val="accent1"/>
+        </a:effectRef>
+        <a:fontRef idx="minor">
+          <a:schemeClr val="tx1"/>
+        </a:fontRef>
+      </a:style>
+    </a:lnDef>
+  </a:objectDefaults>
+  <a:extraClrSchemeLst/>
+  <a:extLst>
+    <a:ext uri="{05A4C25C-085E-4340-85A3-A5531E510DB2}">
+      <thm15:themeFamily xmlns:thm15="http://schemas.microsoft.com/office/thememl/2012/main" name="Office Theme" id="{2E142A2C-CD16-42D6-873A-C26D2A0506FA}" vid="{1BDDFF52-6CD6-40A5-AB3C-68EB2F1E4D0A}"/>
+    </a:ext>
+  </a:extLst>
+</a:theme>
 </file>
</xml_diff>